<commit_message>
Correct chart data label legend key probe
</commit_message>
<xml_diff>
--- a/tests/Lokad.OoxPdf.Tests/Cases/pptx-ladder-11-chart-data-label-legend-keys-probe.pptx
+++ b/tests/Lokad.OoxPdf.Tests/Cases/pptx-ladder-11-chart-data-label-legend-keys-probe.pptx
@@ -153,6 +153,40 @@
             </a:ln>
           </c:spPr>
           <c:invertIfNegative val="0"/>
+          <c:dLbls>
+            <c:spPr>
+              <a:noFill/>
+              <a:ln>
+                <a:noFill/>
+              </a:ln>
+              <a:effectLst/>
+            </c:spPr>
+            <c:txPr>
+              <a:bodyPr wrap="square" lIns="38100" tIns="19050" rIns="38100" bIns="19050" anchor="ctr">
+                <a:spAutoFit/>
+              </a:bodyPr>
+              <a:lstStyle/>
+              <a:p>
+                <a:pPr>
+                  <a:defRPr sz="800"/>
+                </a:pPr>
+                <a:endParaRPr lang="en-US"/>
+              </a:p>
+            </c:txPr>
+            <c:dLblPos val="outEnd"/>
+            <c:showLegendKey val="1"/>
+            <c:showVal val="1"/>
+            <c:showCatName val="0"/>
+            <c:showSerName val="0"/>
+            <c:showPercent val="0"/>
+            <c:showBubbleSize val="0"/>
+            <c:showLeaderLines val="0"/>
+            <c:extLst>
+              <c:ext xmlns:c15="http://schemas.microsoft.com/office/drawing/2012/chart" uri="{CE6537A1-D6FC-4f65-9D91-7224C49458BB}">
+                <c15:showLeaderLines val="1"/>
+              </c:ext>
+            </c:extLst>
+          </c:dLbls>
           <c:cat>
             <c:strRef>
               <c:f>Sheet1!$A$2:$A$5</c:f>
@@ -196,7 +230,7 @@
           </c:val>
           <c:extLst>
             <c:ext xmlns:c16="http://schemas.microsoft.com/office/drawing/2014/chart" uri="{C3380CC4-5D6E-409C-BE32-E72D297353CC}">
-              <c16:uniqueId val="{00000000-1003-495B-BB5E-F98CD398807B}"/>
+              <c16:uniqueId val="{00000000-1BA0-45C0-B7A3-DECF5B272610}"/>
             </c:ext>
           </c:extLst>
         </c:ser>
@@ -225,6 +259,40 @@
             </a:ln>
           </c:spPr>
           <c:invertIfNegative val="0"/>
+          <c:dLbls>
+            <c:spPr>
+              <a:noFill/>
+              <a:ln>
+                <a:noFill/>
+              </a:ln>
+              <a:effectLst/>
+            </c:spPr>
+            <c:txPr>
+              <a:bodyPr wrap="square" lIns="38100" tIns="19050" rIns="38100" bIns="19050" anchor="ctr">
+                <a:spAutoFit/>
+              </a:bodyPr>
+              <a:lstStyle/>
+              <a:p>
+                <a:pPr>
+                  <a:defRPr sz="800"/>
+                </a:pPr>
+                <a:endParaRPr lang="en-US"/>
+              </a:p>
+            </c:txPr>
+            <c:dLblPos val="outEnd"/>
+            <c:showLegendKey val="1"/>
+            <c:showVal val="1"/>
+            <c:showCatName val="0"/>
+            <c:showSerName val="0"/>
+            <c:showPercent val="0"/>
+            <c:showBubbleSize val="0"/>
+            <c:showLeaderLines val="0"/>
+            <c:extLst>
+              <c:ext xmlns:c15="http://schemas.microsoft.com/office/drawing/2012/chart" uri="{CE6537A1-D6FC-4f65-9D91-7224C49458BB}">
+                <c15:showLeaderLines val="1"/>
+              </c:ext>
+            </c:extLst>
+          </c:dLbls>
           <c:cat>
             <c:strRef>
               <c:f>Sheet1!$A$2:$A$5</c:f>
@@ -268,7 +336,7 @@
           </c:val>
           <c:extLst>
             <c:ext xmlns:c16="http://schemas.microsoft.com/office/drawing/2014/chart" uri="{C3380CC4-5D6E-409C-BE32-E72D297353CC}">
-              <c16:uniqueId val="{00000001-1003-495B-BB5E-F98CD398807B}"/>
+              <c16:uniqueId val="{00000001-1BA0-45C0-B7A3-DECF5B272610}"/>
             </c:ext>
           </c:extLst>
         </c:ser>
@@ -281,11 +349,11 @@
           <c:showBubbleSize val="0"/>
         </c:dLbls>
         <c:gapWidth val="150"/>
-        <c:axId val="1386752416"/>
-        <c:axId val="175748224"/>
+        <c:axId val="1320426736"/>
+        <c:axId val="1332541472"/>
       </c:barChart>
       <c:catAx>
-        <c:axId val="1386752416"/>
+        <c:axId val="1320426736"/>
         <c:scaling>
           <c:orientation val="minMax"/>
         </c:scaling>
@@ -312,7 +380,7 @@
             <a:endParaRPr lang="en-US"/>
           </a:p>
         </c:txPr>
-        <c:crossAx val="175748224"/>
+        <c:crossAx val="1332541472"/>
         <c:crosses val="autoZero"/>
         <c:auto val="1"/>
         <c:lblAlgn val="ctr"/>
@@ -320,7 +388,7 @@
         <c:noMultiLvlLbl val="0"/>
       </c:catAx>
       <c:valAx>
-        <c:axId val="175748224"/>
+        <c:axId val="1332541472"/>
         <c:scaling>
           <c:orientation val="minMax"/>
           <c:max val="14"/>
@@ -358,7 +426,7 @@
             <a:endParaRPr lang="en-US"/>
           </a:p>
         </c:txPr>
-        <c:crossAx val="1386752416"/>
+        <c:crossAx val="1320426736"/>
         <c:crosses val="autoZero"/>
         <c:crossBetween val="between"/>
         <c:majorUnit val="2"/>
@@ -413,7 +481,7 @@
           <p:cNvPr id="2" name="Title 1">
             <a:extLst>
               <a:ext uri="{FF2B5EF4-FFF2-40B4-BE49-F238E27FC236}">
-                <a16:creationId xmlns:a16="http://schemas.microsoft.com/office/drawing/2014/main" id="{5D9D0F19-791C-6002-04C6-86E25D75A152}"/>
+                <a16:creationId xmlns:a16="http://schemas.microsoft.com/office/drawing/2014/main" id="{25AF0409-FBDE-F5BB-38FC-8FEAAA5343F4}"/>
               </a:ext>
             </a:extLst>
           </p:cNvPr>
@@ -450,7 +518,7 @@
           <p:cNvPr id="3" name="Subtitle 2">
             <a:extLst>
               <a:ext uri="{FF2B5EF4-FFF2-40B4-BE49-F238E27FC236}">
-                <a16:creationId xmlns:a16="http://schemas.microsoft.com/office/drawing/2014/main" id="{DF94E0FC-001E-7F3C-B646-F8732B60A964}"/>
+                <a16:creationId xmlns:a16="http://schemas.microsoft.com/office/drawing/2014/main" id="{1B017BDA-B680-A8AB-8A46-18E0F552A548}"/>
               </a:ext>
             </a:extLst>
           </p:cNvPr>
@@ -520,7 +588,7 @@
           <p:cNvPr id="4" name="Date Placeholder 3">
             <a:extLst>
               <a:ext uri="{FF2B5EF4-FFF2-40B4-BE49-F238E27FC236}">
-                <a16:creationId xmlns:a16="http://schemas.microsoft.com/office/drawing/2014/main" id="{F3547700-ECF7-8FFF-055D-F2158C92275F}"/>
+                <a16:creationId xmlns:a16="http://schemas.microsoft.com/office/drawing/2014/main" id="{5667FF8D-73CB-57C8-14D6-16C11D50875D}"/>
               </a:ext>
             </a:extLst>
           </p:cNvPr>
@@ -536,7 +604,7 @@
           <a:bodyPr/>
           <a:lstStyle/>
           <a:p>
-            <a:fld id="{8257DA77-7CF4-44E1-8AD6-9D4D0A7CF6A0}" type="datetimeFigureOut">
+            <a:fld id="{918732F9-E82D-415A-A9D3-0AF6537188C2}" type="datetimeFigureOut">
               <a:rPr lang="en-US" smtClean="0"/>
               <a:t>5/27/2026</a:t>
             </a:fld>
@@ -549,7 +617,7 @@
           <p:cNvPr id="5" name="Footer Placeholder 4">
             <a:extLst>
               <a:ext uri="{FF2B5EF4-FFF2-40B4-BE49-F238E27FC236}">
-                <a16:creationId xmlns:a16="http://schemas.microsoft.com/office/drawing/2014/main" id="{C8446C6E-C1CC-E055-4432-24393A1D825E}"/>
+                <a16:creationId xmlns:a16="http://schemas.microsoft.com/office/drawing/2014/main" id="{698BC259-884E-0812-655B-402F6D444138}"/>
               </a:ext>
             </a:extLst>
           </p:cNvPr>
@@ -574,7 +642,7 @@
           <p:cNvPr id="6" name="Slide Number Placeholder 5">
             <a:extLst>
               <a:ext uri="{FF2B5EF4-FFF2-40B4-BE49-F238E27FC236}">
-                <a16:creationId xmlns:a16="http://schemas.microsoft.com/office/drawing/2014/main" id="{C69F0CE3-652B-500C-54BE-A1E8DF901A5A}"/>
+                <a16:creationId xmlns:a16="http://schemas.microsoft.com/office/drawing/2014/main" id="{19746E75-3055-DD1C-91B1-69898CCACEE1}"/>
               </a:ext>
             </a:extLst>
           </p:cNvPr>
@@ -590,7 +658,7 @@
           <a:bodyPr/>
           <a:lstStyle/>
           <a:p>
-            <a:fld id="{B16767C5-12E3-4B50-BECE-E09F331917A2}" type="slidenum">
+            <a:fld id="{48E85829-D41B-4648-A682-E9D6673B9551}" type="slidenum">
               <a:rPr lang="en-US" smtClean="0"/>
               <a:t>‹#›</a:t>
             </a:fld>
@@ -601,7 +669,7 @@
     </p:spTree>
     <p:extLst>
       <p:ext uri="{BB962C8B-B14F-4D97-AF65-F5344CB8AC3E}">
-        <p14:creationId xmlns:p14="http://schemas.microsoft.com/office/powerpoint/2010/main" val="509058927"/>
+        <p14:creationId xmlns:p14="http://schemas.microsoft.com/office/powerpoint/2010/main" val="3665897026"/>
       </p:ext>
     </p:extLst>
   </p:cSld>
@@ -633,7 +701,7 @@
           <p:cNvPr id="2" name="Title 1">
             <a:extLst>
               <a:ext uri="{FF2B5EF4-FFF2-40B4-BE49-F238E27FC236}">
-                <a16:creationId xmlns:a16="http://schemas.microsoft.com/office/drawing/2014/main" id="{382A8A58-D226-CD93-13EA-74DD46861186}"/>
+                <a16:creationId xmlns:a16="http://schemas.microsoft.com/office/drawing/2014/main" id="{C97D753E-3A48-E335-DE42-3F7A7DA72203}"/>
               </a:ext>
             </a:extLst>
           </p:cNvPr>
@@ -661,7 +729,7 @@
           <p:cNvPr id="3" name="Vertical Text Placeholder 2">
             <a:extLst>
               <a:ext uri="{FF2B5EF4-FFF2-40B4-BE49-F238E27FC236}">
-                <a16:creationId xmlns:a16="http://schemas.microsoft.com/office/drawing/2014/main" id="{11E18947-ED24-D40A-1506-E89478A3A1AB}"/>
+                <a16:creationId xmlns:a16="http://schemas.microsoft.com/office/drawing/2014/main" id="{317DE0D2-7297-8D74-9A1C-91BADA83521C}"/>
               </a:ext>
             </a:extLst>
           </p:cNvPr>
@@ -718,7 +786,7 @@
           <p:cNvPr id="4" name="Date Placeholder 3">
             <a:extLst>
               <a:ext uri="{FF2B5EF4-FFF2-40B4-BE49-F238E27FC236}">
-                <a16:creationId xmlns:a16="http://schemas.microsoft.com/office/drawing/2014/main" id="{E2160E5B-8D04-BC5D-DF15-B773D073C0DD}"/>
+                <a16:creationId xmlns:a16="http://schemas.microsoft.com/office/drawing/2014/main" id="{B001CEDF-652E-9625-684B-F653B323C957}"/>
               </a:ext>
             </a:extLst>
           </p:cNvPr>
@@ -734,7 +802,7 @@
           <a:bodyPr/>
           <a:lstStyle/>
           <a:p>
-            <a:fld id="{8257DA77-7CF4-44E1-8AD6-9D4D0A7CF6A0}" type="datetimeFigureOut">
+            <a:fld id="{918732F9-E82D-415A-A9D3-0AF6537188C2}" type="datetimeFigureOut">
               <a:rPr lang="en-US" smtClean="0"/>
               <a:t>5/27/2026</a:t>
             </a:fld>
@@ -747,7 +815,7 @@
           <p:cNvPr id="5" name="Footer Placeholder 4">
             <a:extLst>
               <a:ext uri="{FF2B5EF4-FFF2-40B4-BE49-F238E27FC236}">
-                <a16:creationId xmlns:a16="http://schemas.microsoft.com/office/drawing/2014/main" id="{A2FF10CE-AB34-C322-3134-F07CB443F4E2}"/>
+                <a16:creationId xmlns:a16="http://schemas.microsoft.com/office/drawing/2014/main" id="{3533222D-2B27-757C-FF2C-91CD6720BA9F}"/>
               </a:ext>
             </a:extLst>
           </p:cNvPr>
@@ -772,7 +840,7 @@
           <p:cNvPr id="6" name="Slide Number Placeholder 5">
             <a:extLst>
               <a:ext uri="{FF2B5EF4-FFF2-40B4-BE49-F238E27FC236}">
-                <a16:creationId xmlns:a16="http://schemas.microsoft.com/office/drawing/2014/main" id="{D0489DCF-C521-777B-0A92-61229E110B9E}"/>
+                <a16:creationId xmlns:a16="http://schemas.microsoft.com/office/drawing/2014/main" id="{3D4C6B63-84CB-FBBC-8E45-72BAEBCF385B}"/>
               </a:ext>
             </a:extLst>
           </p:cNvPr>
@@ -788,7 +856,7 @@
           <a:bodyPr/>
           <a:lstStyle/>
           <a:p>
-            <a:fld id="{B16767C5-12E3-4B50-BECE-E09F331917A2}" type="slidenum">
+            <a:fld id="{48E85829-D41B-4648-A682-E9D6673B9551}" type="slidenum">
               <a:rPr lang="en-US" smtClean="0"/>
               <a:t>‹#›</a:t>
             </a:fld>
@@ -799,7 +867,7 @@
     </p:spTree>
     <p:extLst>
       <p:ext uri="{BB962C8B-B14F-4D97-AF65-F5344CB8AC3E}">
-        <p14:creationId xmlns:p14="http://schemas.microsoft.com/office/powerpoint/2010/main" val="3757812038"/>
+        <p14:creationId xmlns:p14="http://schemas.microsoft.com/office/powerpoint/2010/main" val="879520438"/>
       </p:ext>
     </p:extLst>
   </p:cSld>
@@ -831,7 +899,7 @@
           <p:cNvPr id="2" name="Vertical Title 1">
             <a:extLst>
               <a:ext uri="{FF2B5EF4-FFF2-40B4-BE49-F238E27FC236}">
-                <a16:creationId xmlns:a16="http://schemas.microsoft.com/office/drawing/2014/main" id="{28B04AEB-D4EA-3F11-27F4-BF87D0CB0BB3}"/>
+                <a16:creationId xmlns:a16="http://schemas.microsoft.com/office/drawing/2014/main" id="{C30039AB-B0B8-C15C-5213-0FEB14C85E26}"/>
               </a:ext>
             </a:extLst>
           </p:cNvPr>
@@ -864,7 +932,7 @@
           <p:cNvPr id="3" name="Vertical Text Placeholder 2">
             <a:extLst>
               <a:ext uri="{FF2B5EF4-FFF2-40B4-BE49-F238E27FC236}">
-                <a16:creationId xmlns:a16="http://schemas.microsoft.com/office/drawing/2014/main" id="{95DFB53B-B397-DC0E-1FBE-7FB93A41957C}"/>
+                <a16:creationId xmlns:a16="http://schemas.microsoft.com/office/drawing/2014/main" id="{9E500F20-15DF-F877-70D4-06E22B0DE9FB}"/>
               </a:ext>
             </a:extLst>
           </p:cNvPr>
@@ -926,7 +994,7 @@
           <p:cNvPr id="4" name="Date Placeholder 3">
             <a:extLst>
               <a:ext uri="{FF2B5EF4-FFF2-40B4-BE49-F238E27FC236}">
-                <a16:creationId xmlns:a16="http://schemas.microsoft.com/office/drawing/2014/main" id="{76064CDD-9EE2-F2AE-1A46-D065DA639235}"/>
+                <a16:creationId xmlns:a16="http://schemas.microsoft.com/office/drawing/2014/main" id="{E0414496-A281-D790-CE77-02212136169F}"/>
               </a:ext>
             </a:extLst>
           </p:cNvPr>
@@ -942,7 +1010,7 @@
           <a:bodyPr/>
           <a:lstStyle/>
           <a:p>
-            <a:fld id="{8257DA77-7CF4-44E1-8AD6-9D4D0A7CF6A0}" type="datetimeFigureOut">
+            <a:fld id="{918732F9-E82D-415A-A9D3-0AF6537188C2}" type="datetimeFigureOut">
               <a:rPr lang="en-US" smtClean="0"/>
               <a:t>5/27/2026</a:t>
             </a:fld>
@@ -955,7 +1023,7 @@
           <p:cNvPr id="5" name="Footer Placeholder 4">
             <a:extLst>
               <a:ext uri="{FF2B5EF4-FFF2-40B4-BE49-F238E27FC236}">
-                <a16:creationId xmlns:a16="http://schemas.microsoft.com/office/drawing/2014/main" id="{504C28CA-6E8D-F763-B3CD-97B68CDEAD08}"/>
+                <a16:creationId xmlns:a16="http://schemas.microsoft.com/office/drawing/2014/main" id="{90025632-FE7F-CB0B-5E28-30D1A67F8547}"/>
               </a:ext>
             </a:extLst>
           </p:cNvPr>
@@ -980,7 +1048,7 @@
           <p:cNvPr id="6" name="Slide Number Placeholder 5">
             <a:extLst>
               <a:ext uri="{FF2B5EF4-FFF2-40B4-BE49-F238E27FC236}">
-                <a16:creationId xmlns:a16="http://schemas.microsoft.com/office/drawing/2014/main" id="{2ADD5DB9-0BD3-90F0-76E2-09B67A2FB562}"/>
+                <a16:creationId xmlns:a16="http://schemas.microsoft.com/office/drawing/2014/main" id="{B1CBC361-A34D-D312-C355-7D3D09FD8258}"/>
               </a:ext>
             </a:extLst>
           </p:cNvPr>
@@ -996,7 +1064,7 @@
           <a:bodyPr/>
           <a:lstStyle/>
           <a:p>
-            <a:fld id="{B16767C5-12E3-4B50-BECE-E09F331917A2}" type="slidenum">
+            <a:fld id="{48E85829-D41B-4648-A682-E9D6673B9551}" type="slidenum">
               <a:rPr lang="en-US" smtClean="0"/>
               <a:t>‹#›</a:t>
             </a:fld>
@@ -1007,7 +1075,7 @@
     </p:spTree>
     <p:extLst>
       <p:ext uri="{BB962C8B-B14F-4D97-AF65-F5344CB8AC3E}">
-        <p14:creationId xmlns:p14="http://schemas.microsoft.com/office/powerpoint/2010/main" val="2775377444"/>
+        <p14:creationId xmlns:p14="http://schemas.microsoft.com/office/powerpoint/2010/main" val="3954207604"/>
       </p:ext>
     </p:extLst>
   </p:cSld>
@@ -1039,7 +1107,7 @@
           <p:cNvPr id="2" name="Title 1">
             <a:extLst>
               <a:ext uri="{FF2B5EF4-FFF2-40B4-BE49-F238E27FC236}">
-                <a16:creationId xmlns:a16="http://schemas.microsoft.com/office/drawing/2014/main" id="{2E7523E9-454B-7547-F6E1-31061CE62CE3}"/>
+                <a16:creationId xmlns:a16="http://schemas.microsoft.com/office/drawing/2014/main" id="{3A87E68A-D60C-96D5-6AD7-88428D492EE9}"/>
               </a:ext>
             </a:extLst>
           </p:cNvPr>
@@ -1067,7 +1135,7 @@
           <p:cNvPr id="3" name="Content Placeholder 2">
             <a:extLst>
               <a:ext uri="{FF2B5EF4-FFF2-40B4-BE49-F238E27FC236}">
-                <a16:creationId xmlns:a16="http://schemas.microsoft.com/office/drawing/2014/main" id="{56EA796A-3425-24A0-9593-A599BCA42283}"/>
+                <a16:creationId xmlns:a16="http://schemas.microsoft.com/office/drawing/2014/main" id="{2215DB14-98F9-148B-F954-527C54B8211B}"/>
               </a:ext>
             </a:extLst>
           </p:cNvPr>
@@ -1124,7 +1192,7 @@
           <p:cNvPr id="4" name="Date Placeholder 3">
             <a:extLst>
               <a:ext uri="{FF2B5EF4-FFF2-40B4-BE49-F238E27FC236}">
-                <a16:creationId xmlns:a16="http://schemas.microsoft.com/office/drawing/2014/main" id="{F90D8654-8288-59FB-EDB1-D012DE454C11}"/>
+                <a16:creationId xmlns:a16="http://schemas.microsoft.com/office/drawing/2014/main" id="{C9B757C4-86B7-4F08-B380-13380D44F32D}"/>
               </a:ext>
             </a:extLst>
           </p:cNvPr>
@@ -1140,7 +1208,7 @@
           <a:bodyPr/>
           <a:lstStyle/>
           <a:p>
-            <a:fld id="{8257DA77-7CF4-44E1-8AD6-9D4D0A7CF6A0}" type="datetimeFigureOut">
+            <a:fld id="{918732F9-E82D-415A-A9D3-0AF6537188C2}" type="datetimeFigureOut">
               <a:rPr lang="en-US" smtClean="0"/>
               <a:t>5/27/2026</a:t>
             </a:fld>
@@ -1153,7 +1221,7 @@
           <p:cNvPr id="5" name="Footer Placeholder 4">
             <a:extLst>
               <a:ext uri="{FF2B5EF4-FFF2-40B4-BE49-F238E27FC236}">
-                <a16:creationId xmlns:a16="http://schemas.microsoft.com/office/drawing/2014/main" id="{32D29C9E-8B5F-6161-C713-F189DE814CB0}"/>
+                <a16:creationId xmlns:a16="http://schemas.microsoft.com/office/drawing/2014/main" id="{6B375508-FD6C-83EC-EDBA-C277FB027205}"/>
               </a:ext>
             </a:extLst>
           </p:cNvPr>
@@ -1178,7 +1246,7 @@
           <p:cNvPr id="6" name="Slide Number Placeholder 5">
             <a:extLst>
               <a:ext uri="{FF2B5EF4-FFF2-40B4-BE49-F238E27FC236}">
-                <a16:creationId xmlns:a16="http://schemas.microsoft.com/office/drawing/2014/main" id="{7377E3CB-B76D-BD44-05FB-033588716F4B}"/>
+                <a16:creationId xmlns:a16="http://schemas.microsoft.com/office/drawing/2014/main" id="{9C255B61-17A3-E0ED-9256-237746758220}"/>
               </a:ext>
             </a:extLst>
           </p:cNvPr>
@@ -1194,7 +1262,7 @@
           <a:bodyPr/>
           <a:lstStyle/>
           <a:p>
-            <a:fld id="{B16767C5-12E3-4B50-BECE-E09F331917A2}" type="slidenum">
+            <a:fld id="{48E85829-D41B-4648-A682-E9D6673B9551}" type="slidenum">
               <a:rPr lang="en-US" smtClean="0"/>
               <a:t>‹#›</a:t>
             </a:fld>
@@ -1205,7 +1273,7 @@
     </p:spTree>
     <p:extLst>
       <p:ext uri="{BB962C8B-B14F-4D97-AF65-F5344CB8AC3E}">
-        <p14:creationId xmlns:p14="http://schemas.microsoft.com/office/powerpoint/2010/main" val="2233857211"/>
+        <p14:creationId xmlns:p14="http://schemas.microsoft.com/office/powerpoint/2010/main" val="980644156"/>
       </p:ext>
     </p:extLst>
   </p:cSld>
@@ -1237,7 +1305,7 @@
           <p:cNvPr id="2" name="Title 1">
             <a:extLst>
               <a:ext uri="{FF2B5EF4-FFF2-40B4-BE49-F238E27FC236}">
-                <a16:creationId xmlns:a16="http://schemas.microsoft.com/office/drawing/2014/main" id="{3385E9FC-02D7-BDD3-6B9C-BE6C41BD5E2D}"/>
+                <a16:creationId xmlns:a16="http://schemas.microsoft.com/office/drawing/2014/main" id="{9719443C-AC61-726A-DF8D-04DC1859FA14}"/>
               </a:ext>
             </a:extLst>
           </p:cNvPr>
@@ -1274,7 +1342,7 @@
           <p:cNvPr id="3" name="Text Placeholder 2">
             <a:extLst>
               <a:ext uri="{FF2B5EF4-FFF2-40B4-BE49-F238E27FC236}">
-                <a16:creationId xmlns:a16="http://schemas.microsoft.com/office/drawing/2014/main" id="{FD193A6B-C280-2AC6-6C69-1B1FAD7B34A7}"/>
+                <a16:creationId xmlns:a16="http://schemas.microsoft.com/office/drawing/2014/main" id="{38BDF1EE-9DD5-468D-48B2-4F5239BFBA3C}"/>
               </a:ext>
             </a:extLst>
           </p:cNvPr>
@@ -1399,7 +1467,7 @@
           <p:cNvPr id="4" name="Date Placeholder 3">
             <a:extLst>
               <a:ext uri="{FF2B5EF4-FFF2-40B4-BE49-F238E27FC236}">
-                <a16:creationId xmlns:a16="http://schemas.microsoft.com/office/drawing/2014/main" id="{D2AE6291-906F-FA7F-5C01-66C12B9E2C03}"/>
+                <a16:creationId xmlns:a16="http://schemas.microsoft.com/office/drawing/2014/main" id="{83C136F3-0250-61BC-BD36-DC56E9D980EB}"/>
               </a:ext>
             </a:extLst>
           </p:cNvPr>
@@ -1415,7 +1483,7 @@
           <a:bodyPr/>
           <a:lstStyle/>
           <a:p>
-            <a:fld id="{8257DA77-7CF4-44E1-8AD6-9D4D0A7CF6A0}" type="datetimeFigureOut">
+            <a:fld id="{918732F9-E82D-415A-A9D3-0AF6537188C2}" type="datetimeFigureOut">
               <a:rPr lang="en-US" smtClean="0"/>
               <a:t>5/27/2026</a:t>
             </a:fld>
@@ -1428,7 +1496,7 @@
           <p:cNvPr id="5" name="Footer Placeholder 4">
             <a:extLst>
               <a:ext uri="{FF2B5EF4-FFF2-40B4-BE49-F238E27FC236}">
-                <a16:creationId xmlns:a16="http://schemas.microsoft.com/office/drawing/2014/main" id="{F1CDF173-8CBB-254C-79BB-CCCB6A71E998}"/>
+                <a16:creationId xmlns:a16="http://schemas.microsoft.com/office/drawing/2014/main" id="{117ECDD2-F73E-D874-8A2E-824305E1A130}"/>
               </a:ext>
             </a:extLst>
           </p:cNvPr>
@@ -1453,7 +1521,7 @@
           <p:cNvPr id="6" name="Slide Number Placeholder 5">
             <a:extLst>
               <a:ext uri="{FF2B5EF4-FFF2-40B4-BE49-F238E27FC236}">
-                <a16:creationId xmlns:a16="http://schemas.microsoft.com/office/drawing/2014/main" id="{6035EBF6-95AB-3805-6CF3-80B107C104F1}"/>
+                <a16:creationId xmlns:a16="http://schemas.microsoft.com/office/drawing/2014/main" id="{910BADF6-6D5C-EA72-9DF0-5DCA72E8BD80}"/>
               </a:ext>
             </a:extLst>
           </p:cNvPr>
@@ -1469,7 +1537,7 @@
           <a:bodyPr/>
           <a:lstStyle/>
           <a:p>
-            <a:fld id="{B16767C5-12E3-4B50-BECE-E09F331917A2}" type="slidenum">
+            <a:fld id="{48E85829-D41B-4648-A682-E9D6673B9551}" type="slidenum">
               <a:rPr lang="en-US" smtClean="0"/>
               <a:t>‹#›</a:t>
             </a:fld>
@@ -1480,7 +1548,7 @@
     </p:spTree>
     <p:extLst>
       <p:ext uri="{BB962C8B-B14F-4D97-AF65-F5344CB8AC3E}">
-        <p14:creationId xmlns:p14="http://schemas.microsoft.com/office/powerpoint/2010/main" val="2018694787"/>
+        <p14:creationId xmlns:p14="http://schemas.microsoft.com/office/powerpoint/2010/main" val="2744490245"/>
       </p:ext>
     </p:extLst>
   </p:cSld>
@@ -1512,7 +1580,7 @@
           <p:cNvPr id="2" name="Title 1">
             <a:extLst>
               <a:ext uri="{FF2B5EF4-FFF2-40B4-BE49-F238E27FC236}">
-                <a16:creationId xmlns:a16="http://schemas.microsoft.com/office/drawing/2014/main" id="{B56B48BB-6DF0-691C-A725-507B8866A2D4}"/>
+                <a16:creationId xmlns:a16="http://schemas.microsoft.com/office/drawing/2014/main" id="{B9361047-25AA-E43E-3578-1E7CF3C6AF33}"/>
               </a:ext>
             </a:extLst>
           </p:cNvPr>
@@ -1540,7 +1608,7 @@
           <p:cNvPr id="3" name="Content Placeholder 2">
             <a:extLst>
               <a:ext uri="{FF2B5EF4-FFF2-40B4-BE49-F238E27FC236}">
-                <a16:creationId xmlns:a16="http://schemas.microsoft.com/office/drawing/2014/main" id="{33F69C9F-4AF1-350F-8543-791949E79E49}"/>
+                <a16:creationId xmlns:a16="http://schemas.microsoft.com/office/drawing/2014/main" id="{EDBB14E9-99BE-B79E-24D1-0DB714CF74F2}"/>
               </a:ext>
             </a:extLst>
           </p:cNvPr>
@@ -1602,7 +1670,7 @@
           <p:cNvPr id="4" name="Content Placeholder 3">
             <a:extLst>
               <a:ext uri="{FF2B5EF4-FFF2-40B4-BE49-F238E27FC236}">
-                <a16:creationId xmlns:a16="http://schemas.microsoft.com/office/drawing/2014/main" id="{58C609C6-9346-B6ED-0BD9-B3E3B303105D}"/>
+                <a16:creationId xmlns:a16="http://schemas.microsoft.com/office/drawing/2014/main" id="{1F85D0CE-78B9-31E0-9243-BAEC6716766C}"/>
               </a:ext>
             </a:extLst>
           </p:cNvPr>
@@ -1664,7 +1732,7 @@
           <p:cNvPr id="5" name="Date Placeholder 4">
             <a:extLst>
               <a:ext uri="{FF2B5EF4-FFF2-40B4-BE49-F238E27FC236}">
-                <a16:creationId xmlns:a16="http://schemas.microsoft.com/office/drawing/2014/main" id="{7D43C4B1-BEC2-0A02-4ED7-E9A77F216D73}"/>
+                <a16:creationId xmlns:a16="http://schemas.microsoft.com/office/drawing/2014/main" id="{186A7C3D-B8C9-52C7-8E48-FFF97EE2EBAE}"/>
               </a:ext>
             </a:extLst>
           </p:cNvPr>
@@ -1680,7 +1748,7 @@
           <a:bodyPr/>
           <a:lstStyle/>
           <a:p>
-            <a:fld id="{8257DA77-7CF4-44E1-8AD6-9D4D0A7CF6A0}" type="datetimeFigureOut">
+            <a:fld id="{918732F9-E82D-415A-A9D3-0AF6537188C2}" type="datetimeFigureOut">
               <a:rPr lang="en-US" smtClean="0"/>
               <a:t>5/27/2026</a:t>
             </a:fld>
@@ -1693,7 +1761,7 @@
           <p:cNvPr id="6" name="Footer Placeholder 5">
             <a:extLst>
               <a:ext uri="{FF2B5EF4-FFF2-40B4-BE49-F238E27FC236}">
-                <a16:creationId xmlns:a16="http://schemas.microsoft.com/office/drawing/2014/main" id="{19B20FDB-CA93-CE6A-8C61-1140577F95F4}"/>
+                <a16:creationId xmlns:a16="http://schemas.microsoft.com/office/drawing/2014/main" id="{E620632B-265F-0633-1F90-09A30B3EFB34}"/>
               </a:ext>
             </a:extLst>
           </p:cNvPr>
@@ -1718,7 +1786,7 @@
           <p:cNvPr id="7" name="Slide Number Placeholder 6">
             <a:extLst>
               <a:ext uri="{FF2B5EF4-FFF2-40B4-BE49-F238E27FC236}">
-                <a16:creationId xmlns:a16="http://schemas.microsoft.com/office/drawing/2014/main" id="{E5F73FB7-7FF7-2F11-47AC-122BBDFE6C07}"/>
+                <a16:creationId xmlns:a16="http://schemas.microsoft.com/office/drawing/2014/main" id="{CBBCE58E-C3C8-D4D1-1B28-D78FA0AFF101}"/>
               </a:ext>
             </a:extLst>
           </p:cNvPr>
@@ -1734,7 +1802,7 @@
           <a:bodyPr/>
           <a:lstStyle/>
           <a:p>
-            <a:fld id="{B16767C5-12E3-4B50-BECE-E09F331917A2}" type="slidenum">
+            <a:fld id="{48E85829-D41B-4648-A682-E9D6673B9551}" type="slidenum">
               <a:rPr lang="en-US" smtClean="0"/>
               <a:t>‹#›</a:t>
             </a:fld>
@@ -1745,7 +1813,7 @@
     </p:spTree>
     <p:extLst>
       <p:ext uri="{BB962C8B-B14F-4D97-AF65-F5344CB8AC3E}">
-        <p14:creationId xmlns:p14="http://schemas.microsoft.com/office/powerpoint/2010/main" val="3272817544"/>
+        <p14:creationId xmlns:p14="http://schemas.microsoft.com/office/powerpoint/2010/main" val="1666523815"/>
       </p:ext>
     </p:extLst>
   </p:cSld>
@@ -1777,7 +1845,7 @@
           <p:cNvPr id="2" name="Title 1">
             <a:extLst>
               <a:ext uri="{FF2B5EF4-FFF2-40B4-BE49-F238E27FC236}">
-                <a16:creationId xmlns:a16="http://schemas.microsoft.com/office/drawing/2014/main" id="{049FE976-2EFB-BDF9-C6C6-BD86F01E3B12}"/>
+                <a16:creationId xmlns:a16="http://schemas.microsoft.com/office/drawing/2014/main" id="{2F1D7975-49F5-BAFB-03E5-3FDEC36A17FA}"/>
               </a:ext>
             </a:extLst>
           </p:cNvPr>
@@ -1810,7 +1878,7 @@
           <p:cNvPr id="3" name="Text Placeholder 2">
             <a:extLst>
               <a:ext uri="{FF2B5EF4-FFF2-40B4-BE49-F238E27FC236}">
-                <a16:creationId xmlns:a16="http://schemas.microsoft.com/office/drawing/2014/main" id="{9A267FF8-0A20-F8C4-BA64-473CDD4058D9}"/>
+                <a16:creationId xmlns:a16="http://schemas.microsoft.com/office/drawing/2014/main" id="{E7307A45-8B24-E221-46FA-478A70F0CC2D}"/>
               </a:ext>
             </a:extLst>
           </p:cNvPr>
@@ -1881,7 +1949,7 @@
           <p:cNvPr id="4" name="Content Placeholder 3">
             <a:extLst>
               <a:ext uri="{FF2B5EF4-FFF2-40B4-BE49-F238E27FC236}">
-                <a16:creationId xmlns:a16="http://schemas.microsoft.com/office/drawing/2014/main" id="{AD40C3DA-CAA0-75A3-F79E-C827E0CEAF56}"/>
+                <a16:creationId xmlns:a16="http://schemas.microsoft.com/office/drawing/2014/main" id="{82AA3F0A-4D61-D52D-D8B6-336C5A700DB4}"/>
               </a:ext>
             </a:extLst>
           </p:cNvPr>
@@ -1943,7 +2011,7 @@
           <p:cNvPr id="5" name="Text Placeholder 4">
             <a:extLst>
               <a:ext uri="{FF2B5EF4-FFF2-40B4-BE49-F238E27FC236}">
-                <a16:creationId xmlns:a16="http://schemas.microsoft.com/office/drawing/2014/main" id="{DD5B9806-AD17-D204-A037-6CF4CB15AA11}"/>
+                <a16:creationId xmlns:a16="http://schemas.microsoft.com/office/drawing/2014/main" id="{04BBDBB5-1181-81B7-85AF-611D3DF49D45}"/>
               </a:ext>
             </a:extLst>
           </p:cNvPr>
@@ -2014,7 +2082,7 @@
           <p:cNvPr id="6" name="Content Placeholder 5">
             <a:extLst>
               <a:ext uri="{FF2B5EF4-FFF2-40B4-BE49-F238E27FC236}">
-                <a16:creationId xmlns:a16="http://schemas.microsoft.com/office/drawing/2014/main" id="{1F417853-0E6B-DBE5-1E96-7FC75EC74B7A}"/>
+                <a16:creationId xmlns:a16="http://schemas.microsoft.com/office/drawing/2014/main" id="{512F0A7C-811D-6C9A-4882-62BC54A99B66}"/>
               </a:ext>
             </a:extLst>
           </p:cNvPr>
@@ -2076,7 +2144,7 @@
           <p:cNvPr id="7" name="Date Placeholder 6">
             <a:extLst>
               <a:ext uri="{FF2B5EF4-FFF2-40B4-BE49-F238E27FC236}">
-                <a16:creationId xmlns:a16="http://schemas.microsoft.com/office/drawing/2014/main" id="{E39FC10B-A87B-0A74-C8C8-D2C14DE3D3ED}"/>
+                <a16:creationId xmlns:a16="http://schemas.microsoft.com/office/drawing/2014/main" id="{8B13A1E1-5CCD-0678-9218-385EEC8F8F88}"/>
               </a:ext>
             </a:extLst>
           </p:cNvPr>
@@ -2092,7 +2160,7 @@
           <a:bodyPr/>
           <a:lstStyle/>
           <a:p>
-            <a:fld id="{8257DA77-7CF4-44E1-8AD6-9D4D0A7CF6A0}" type="datetimeFigureOut">
+            <a:fld id="{918732F9-E82D-415A-A9D3-0AF6537188C2}" type="datetimeFigureOut">
               <a:rPr lang="en-US" smtClean="0"/>
               <a:t>5/27/2026</a:t>
             </a:fld>
@@ -2105,7 +2173,7 @@
           <p:cNvPr id="8" name="Footer Placeholder 7">
             <a:extLst>
               <a:ext uri="{FF2B5EF4-FFF2-40B4-BE49-F238E27FC236}">
-                <a16:creationId xmlns:a16="http://schemas.microsoft.com/office/drawing/2014/main" id="{840A58E2-51D3-1EBC-DA68-33DF6D9F5B20}"/>
+                <a16:creationId xmlns:a16="http://schemas.microsoft.com/office/drawing/2014/main" id="{FA9F6E62-21A1-A6BF-581C-5B6E32C28535}"/>
               </a:ext>
             </a:extLst>
           </p:cNvPr>
@@ -2130,7 +2198,7 @@
           <p:cNvPr id="9" name="Slide Number Placeholder 8">
             <a:extLst>
               <a:ext uri="{FF2B5EF4-FFF2-40B4-BE49-F238E27FC236}">
-                <a16:creationId xmlns:a16="http://schemas.microsoft.com/office/drawing/2014/main" id="{580D41C2-476C-EDDD-8700-05EF84C4F386}"/>
+                <a16:creationId xmlns:a16="http://schemas.microsoft.com/office/drawing/2014/main" id="{B9D4DADD-C31E-F589-AD72-69446EFCD01A}"/>
               </a:ext>
             </a:extLst>
           </p:cNvPr>
@@ -2146,7 +2214,7 @@
           <a:bodyPr/>
           <a:lstStyle/>
           <a:p>
-            <a:fld id="{B16767C5-12E3-4B50-BECE-E09F331917A2}" type="slidenum">
+            <a:fld id="{48E85829-D41B-4648-A682-E9D6673B9551}" type="slidenum">
               <a:rPr lang="en-US" smtClean="0"/>
               <a:t>‹#›</a:t>
             </a:fld>
@@ -2157,7 +2225,7 @@
     </p:spTree>
     <p:extLst>
       <p:ext uri="{BB962C8B-B14F-4D97-AF65-F5344CB8AC3E}">
-        <p14:creationId xmlns:p14="http://schemas.microsoft.com/office/powerpoint/2010/main" val="1535592741"/>
+        <p14:creationId xmlns:p14="http://schemas.microsoft.com/office/powerpoint/2010/main" val="49812956"/>
       </p:ext>
     </p:extLst>
   </p:cSld>
@@ -2189,7 +2257,7 @@
           <p:cNvPr id="2" name="Title 1">
             <a:extLst>
               <a:ext uri="{FF2B5EF4-FFF2-40B4-BE49-F238E27FC236}">
-                <a16:creationId xmlns:a16="http://schemas.microsoft.com/office/drawing/2014/main" id="{36DBF889-C592-FA19-F993-D24C799DE248}"/>
+                <a16:creationId xmlns:a16="http://schemas.microsoft.com/office/drawing/2014/main" id="{9E131549-C570-C000-EB6C-9C73945C36C4}"/>
               </a:ext>
             </a:extLst>
           </p:cNvPr>
@@ -2217,7 +2285,7 @@
           <p:cNvPr id="3" name="Date Placeholder 2">
             <a:extLst>
               <a:ext uri="{FF2B5EF4-FFF2-40B4-BE49-F238E27FC236}">
-                <a16:creationId xmlns:a16="http://schemas.microsoft.com/office/drawing/2014/main" id="{0CD6523E-AB2C-414A-274C-FAA4D4215EC2}"/>
+                <a16:creationId xmlns:a16="http://schemas.microsoft.com/office/drawing/2014/main" id="{2EDECF09-BF57-57E3-5807-FF0DEA6C03B8}"/>
               </a:ext>
             </a:extLst>
           </p:cNvPr>
@@ -2233,7 +2301,7 @@
           <a:bodyPr/>
           <a:lstStyle/>
           <a:p>
-            <a:fld id="{8257DA77-7CF4-44E1-8AD6-9D4D0A7CF6A0}" type="datetimeFigureOut">
+            <a:fld id="{918732F9-E82D-415A-A9D3-0AF6537188C2}" type="datetimeFigureOut">
               <a:rPr lang="en-US" smtClean="0"/>
               <a:t>5/27/2026</a:t>
             </a:fld>
@@ -2246,7 +2314,7 @@
           <p:cNvPr id="4" name="Footer Placeholder 3">
             <a:extLst>
               <a:ext uri="{FF2B5EF4-FFF2-40B4-BE49-F238E27FC236}">
-                <a16:creationId xmlns:a16="http://schemas.microsoft.com/office/drawing/2014/main" id="{DFC5F66B-8333-0D4E-CFE4-1799CAA48CB4}"/>
+                <a16:creationId xmlns:a16="http://schemas.microsoft.com/office/drawing/2014/main" id="{F5C5B8E5-D663-AD1E-360A-B890BC95A3F2}"/>
               </a:ext>
             </a:extLst>
           </p:cNvPr>
@@ -2271,7 +2339,7 @@
           <p:cNvPr id="5" name="Slide Number Placeholder 4">
             <a:extLst>
               <a:ext uri="{FF2B5EF4-FFF2-40B4-BE49-F238E27FC236}">
-                <a16:creationId xmlns:a16="http://schemas.microsoft.com/office/drawing/2014/main" id="{B8D16810-AD1B-5EFD-A259-F3936EA319D5}"/>
+                <a16:creationId xmlns:a16="http://schemas.microsoft.com/office/drawing/2014/main" id="{5F35D764-984F-A8E1-14E4-264F3FCF07F5}"/>
               </a:ext>
             </a:extLst>
           </p:cNvPr>
@@ -2287,7 +2355,7 @@
           <a:bodyPr/>
           <a:lstStyle/>
           <a:p>
-            <a:fld id="{B16767C5-12E3-4B50-BECE-E09F331917A2}" type="slidenum">
+            <a:fld id="{48E85829-D41B-4648-A682-E9D6673B9551}" type="slidenum">
               <a:rPr lang="en-US" smtClean="0"/>
               <a:t>‹#›</a:t>
             </a:fld>
@@ -2298,7 +2366,7 @@
     </p:spTree>
     <p:extLst>
       <p:ext uri="{BB962C8B-B14F-4D97-AF65-F5344CB8AC3E}">
-        <p14:creationId xmlns:p14="http://schemas.microsoft.com/office/powerpoint/2010/main" val="493841608"/>
+        <p14:creationId xmlns:p14="http://schemas.microsoft.com/office/powerpoint/2010/main" val="2609184926"/>
       </p:ext>
     </p:extLst>
   </p:cSld>
@@ -2330,7 +2398,7 @@
           <p:cNvPr id="2" name="Date Placeholder 1">
             <a:extLst>
               <a:ext uri="{FF2B5EF4-FFF2-40B4-BE49-F238E27FC236}">
-                <a16:creationId xmlns:a16="http://schemas.microsoft.com/office/drawing/2014/main" id="{1253C824-3CD8-AF9D-8ADF-B0D94CD5EF9D}"/>
+                <a16:creationId xmlns:a16="http://schemas.microsoft.com/office/drawing/2014/main" id="{3D2590D1-FE27-FF61-2756-A3FE0D50AAFF}"/>
               </a:ext>
             </a:extLst>
           </p:cNvPr>
@@ -2346,7 +2414,7 @@
           <a:bodyPr/>
           <a:lstStyle/>
           <a:p>
-            <a:fld id="{8257DA77-7CF4-44E1-8AD6-9D4D0A7CF6A0}" type="datetimeFigureOut">
+            <a:fld id="{918732F9-E82D-415A-A9D3-0AF6537188C2}" type="datetimeFigureOut">
               <a:rPr lang="en-US" smtClean="0"/>
               <a:t>5/27/2026</a:t>
             </a:fld>
@@ -2359,7 +2427,7 @@
           <p:cNvPr id="3" name="Footer Placeholder 2">
             <a:extLst>
               <a:ext uri="{FF2B5EF4-FFF2-40B4-BE49-F238E27FC236}">
-                <a16:creationId xmlns:a16="http://schemas.microsoft.com/office/drawing/2014/main" id="{9A347CB9-6B79-7848-8133-81E96BC607F4}"/>
+                <a16:creationId xmlns:a16="http://schemas.microsoft.com/office/drawing/2014/main" id="{5693B237-FB22-C3D3-BEF7-77A991DFC854}"/>
               </a:ext>
             </a:extLst>
           </p:cNvPr>
@@ -2384,7 +2452,7 @@
           <p:cNvPr id="4" name="Slide Number Placeholder 3">
             <a:extLst>
               <a:ext uri="{FF2B5EF4-FFF2-40B4-BE49-F238E27FC236}">
-                <a16:creationId xmlns:a16="http://schemas.microsoft.com/office/drawing/2014/main" id="{5EFB277D-1241-AC50-1EFD-393F862A1043}"/>
+                <a16:creationId xmlns:a16="http://schemas.microsoft.com/office/drawing/2014/main" id="{610163F4-DD41-6354-878E-081F44C51F91}"/>
               </a:ext>
             </a:extLst>
           </p:cNvPr>
@@ -2400,7 +2468,7 @@
           <a:bodyPr/>
           <a:lstStyle/>
           <a:p>
-            <a:fld id="{B16767C5-12E3-4B50-BECE-E09F331917A2}" type="slidenum">
+            <a:fld id="{48E85829-D41B-4648-A682-E9D6673B9551}" type="slidenum">
               <a:rPr lang="en-US" smtClean="0"/>
               <a:t>‹#›</a:t>
             </a:fld>
@@ -2411,7 +2479,7 @@
     </p:spTree>
     <p:extLst>
       <p:ext uri="{BB962C8B-B14F-4D97-AF65-F5344CB8AC3E}">
-        <p14:creationId xmlns:p14="http://schemas.microsoft.com/office/powerpoint/2010/main" val="40381834"/>
+        <p14:creationId xmlns:p14="http://schemas.microsoft.com/office/powerpoint/2010/main" val="903044666"/>
       </p:ext>
     </p:extLst>
   </p:cSld>
@@ -2443,7 +2511,7 @@
           <p:cNvPr id="2" name="Title 1">
             <a:extLst>
               <a:ext uri="{FF2B5EF4-FFF2-40B4-BE49-F238E27FC236}">
-                <a16:creationId xmlns:a16="http://schemas.microsoft.com/office/drawing/2014/main" id="{454EFB9A-4BDA-387C-EE28-2CBB861B1307}"/>
+                <a16:creationId xmlns:a16="http://schemas.microsoft.com/office/drawing/2014/main" id="{73FD3186-CCEE-E66F-F12F-C000D408BF48}"/>
               </a:ext>
             </a:extLst>
           </p:cNvPr>
@@ -2480,7 +2548,7 @@
           <p:cNvPr id="3" name="Content Placeholder 2">
             <a:extLst>
               <a:ext uri="{FF2B5EF4-FFF2-40B4-BE49-F238E27FC236}">
-                <a16:creationId xmlns:a16="http://schemas.microsoft.com/office/drawing/2014/main" id="{FAE4EAC9-0B44-3EBF-659E-9B39DAC86C62}"/>
+                <a16:creationId xmlns:a16="http://schemas.microsoft.com/office/drawing/2014/main" id="{AEECFDF7-7955-C71F-5953-12152519F842}"/>
               </a:ext>
             </a:extLst>
           </p:cNvPr>
@@ -2570,7 +2638,7 @@
           <p:cNvPr id="4" name="Text Placeholder 3">
             <a:extLst>
               <a:ext uri="{FF2B5EF4-FFF2-40B4-BE49-F238E27FC236}">
-                <a16:creationId xmlns:a16="http://schemas.microsoft.com/office/drawing/2014/main" id="{CAFF5B1B-AB7E-927E-8F82-76A3ED4CAC9F}"/>
+                <a16:creationId xmlns:a16="http://schemas.microsoft.com/office/drawing/2014/main" id="{C00A42DA-65C5-D303-F56B-25BB20094F7C}"/>
               </a:ext>
             </a:extLst>
           </p:cNvPr>
@@ -2641,7 +2709,7 @@
           <p:cNvPr id="5" name="Date Placeholder 4">
             <a:extLst>
               <a:ext uri="{FF2B5EF4-FFF2-40B4-BE49-F238E27FC236}">
-                <a16:creationId xmlns:a16="http://schemas.microsoft.com/office/drawing/2014/main" id="{9ACD8C12-0C91-309E-B311-6CA926E39903}"/>
+                <a16:creationId xmlns:a16="http://schemas.microsoft.com/office/drawing/2014/main" id="{3BC20096-F78B-8167-1B3D-FC1DC5607C65}"/>
               </a:ext>
             </a:extLst>
           </p:cNvPr>
@@ -2657,7 +2725,7 @@
           <a:bodyPr/>
           <a:lstStyle/>
           <a:p>
-            <a:fld id="{8257DA77-7CF4-44E1-8AD6-9D4D0A7CF6A0}" type="datetimeFigureOut">
+            <a:fld id="{918732F9-E82D-415A-A9D3-0AF6537188C2}" type="datetimeFigureOut">
               <a:rPr lang="en-US" smtClean="0"/>
               <a:t>5/27/2026</a:t>
             </a:fld>
@@ -2670,7 +2738,7 @@
           <p:cNvPr id="6" name="Footer Placeholder 5">
             <a:extLst>
               <a:ext uri="{FF2B5EF4-FFF2-40B4-BE49-F238E27FC236}">
-                <a16:creationId xmlns:a16="http://schemas.microsoft.com/office/drawing/2014/main" id="{F39A5320-BC07-B5DF-B57E-37315B53EE62}"/>
+                <a16:creationId xmlns:a16="http://schemas.microsoft.com/office/drawing/2014/main" id="{E4D74AA2-B8D1-13FA-4674-CAD61E3423B7}"/>
               </a:ext>
             </a:extLst>
           </p:cNvPr>
@@ -2695,7 +2763,7 @@
           <p:cNvPr id="7" name="Slide Number Placeholder 6">
             <a:extLst>
               <a:ext uri="{FF2B5EF4-FFF2-40B4-BE49-F238E27FC236}">
-                <a16:creationId xmlns:a16="http://schemas.microsoft.com/office/drawing/2014/main" id="{290FAC3A-841C-DBA7-21E6-394F74E03ED6}"/>
+                <a16:creationId xmlns:a16="http://schemas.microsoft.com/office/drawing/2014/main" id="{F76FC519-C9C4-56D3-49F0-ACEE13764BB2}"/>
               </a:ext>
             </a:extLst>
           </p:cNvPr>
@@ -2711,7 +2779,7 @@
           <a:bodyPr/>
           <a:lstStyle/>
           <a:p>
-            <a:fld id="{B16767C5-12E3-4B50-BECE-E09F331917A2}" type="slidenum">
+            <a:fld id="{48E85829-D41B-4648-A682-E9D6673B9551}" type="slidenum">
               <a:rPr lang="en-US" smtClean="0"/>
               <a:t>‹#›</a:t>
             </a:fld>
@@ -2722,7 +2790,7 @@
     </p:spTree>
     <p:extLst>
       <p:ext uri="{BB962C8B-B14F-4D97-AF65-F5344CB8AC3E}">
-        <p14:creationId xmlns:p14="http://schemas.microsoft.com/office/powerpoint/2010/main" val="2825331366"/>
+        <p14:creationId xmlns:p14="http://schemas.microsoft.com/office/powerpoint/2010/main" val="222665481"/>
       </p:ext>
     </p:extLst>
   </p:cSld>
@@ -2754,7 +2822,7 @@
           <p:cNvPr id="2" name="Title 1">
             <a:extLst>
               <a:ext uri="{FF2B5EF4-FFF2-40B4-BE49-F238E27FC236}">
-                <a16:creationId xmlns:a16="http://schemas.microsoft.com/office/drawing/2014/main" id="{EA97A9A5-CE17-2BAE-E36C-FA90B5949F6D}"/>
+                <a16:creationId xmlns:a16="http://schemas.microsoft.com/office/drawing/2014/main" id="{5D2224A0-0896-93FD-C32E-E1FBBC929E1A}"/>
               </a:ext>
             </a:extLst>
           </p:cNvPr>
@@ -2791,7 +2859,7 @@
           <p:cNvPr id="3" name="Picture Placeholder 2">
             <a:extLst>
               <a:ext uri="{FF2B5EF4-FFF2-40B4-BE49-F238E27FC236}">
-                <a16:creationId xmlns:a16="http://schemas.microsoft.com/office/drawing/2014/main" id="{B9BE5118-A69A-9646-E55A-30B8480E617B}"/>
+                <a16:creationId xmlns:a16="http://schemas.microsoft.com/office/drawing/2014/main" id="{59560A7E-3157-A8C5-7BEB-C11F4D02DD95}"/>
               </a:ext>
             </a:extLst>
           </p:cNvPr>
@@ -2858,7 +2926,7 @@
           <p:cNvPr id="4" name="Text Placeholder 3">
             <a:extLst>
               <a:ext uri="{FF2B5EF4-FFF2-40B4-BE49-F238E27FC236}">
-                <a16:creationId xmlns:a16="http://schemas.microsoft.com/office/drawing/2014/main" id="{3F47DF7F-6BA9-5679-F3F9-729B16063244}"/>
+                <a16:creationId xmlns:a16="http://schemas.microsoft.com/office/drawing/2014/main" id="{ED01CA26-924D-5F0E-6566-B1733184FC92}"/>
               </a:ext>
             </a:extLst>
           </p:cNvPr>
@@ -2929,7 +2997,7 @@
           <p:cNvPr id="5" name="Date Placeholder 4">
             <a:extLst>
               <a:ext uri="{FF2B5EF4-FFF2-40B4-BE49-F238E27FC236}">
-                <a16:creationId xmlns:a16="http://schemas.microsoft.com/office/drawing/2014/main" id="{9D6A0A4C-EF58-F670-B50A-AC57D11A724A}"/>
+                <a16:creationId xmlns:a16="http://schemas.microsoft.com/office/drawing/2014/main" id="{5E42942C-1EBF-0370-1CF2-B1A5C72F9C03}"/>
               </a:ext>
             </a:extLst>
           </p:cNvPr>
@@ -2945,7 +3013,7 @@
           <a:bodyPr/>
           <a:lstStyle/>
           <a:p>
-            <a:fld id="{8257DA77-7CF4-44E1-8AD6-9D4D0A7CF6A0}" type="datetimeFigureOut">
+            <a:fld id="{918732F9-E82D-415A-A9D3-0AF6537188C2}" type="datetimeFigureOut">
               <a:rPr lang="en-US" smtClean="0"/>
               <a:t>5/27/2026</a:t>
             </a:fld>
@@ -2958,7 +3026,7 @@
           <p:cNvPr id="6" name="Footer Placeholder 5">
             <a:extLst>
               <a:ext uri="{FF2B5EF4-FFF2-40B4-BE49-F238E27FC236}">
-                <a16:creationId xmlns:a16="http://schemas.microsoft.com/office/drawing/2014/main" id="{6E4C6CB4-DA88-17EB-B2EF-C9D7C6A6A79D}"/>
+                <a16:creationId xmlns:a16="http://schemas.microsoft.com/office/drawing/2014/main" id="{332F48A9-24C4-145A-0ED6-3A50250214DB}"/>
               </a:ext>
             </a:extLst>
           </p:cNvPr>
@@ -2983,7 +3051,7 @@
           <p:cNvPr id="7" name="Slide Number Placeholder 6">
             <a:extLst>
               <a:ext uri="{FF2B5EF4-FFF2-40B4-BE49-F238E27FC236}">
-                <a16:creationId xmlns:a16="http://schemas.microsoft.com/office/drawing/2014/main" id="{755EAECB-B1EF-8C2E-6E04-AFBB32937FE2}"/>
+                <a16:creationId xmlns:a16="http://schemas.microsoft.com/office/drawing/2014/main" id="{3014F024-9722-B064-8234-64962CDCF06F}"/>
               </a:ext>
             </a:extLst>
           </p:cNvPr>
@@ -2999,7 +3067,7 @@
           <a:bodyPr/>
           <a:lstStyle/>
           <a:p>
-            <a:fld id="{B16767C5-12E3-4B50-BECE-E09F331917A2}" type="slidenum">
+            <a:fld id="{48E85829-D41B-4648-A682-E9D6673B9551}" type="slidenum">
               <a:rPr lang="en-US" smtClean="0"/>
               <a:t>‹#›</a:t>
             </a:fld>
@@ -3010,7 +3078,7 @@
     </p:spTree>
     <p:extLst>
       <p:ext uri="{BB962C8B-B14F-4D97-AF65-F5344CB8AC3E}">
-        <p14:creationId xmlns:p14="http://schemas.microsoft.com/office/powerpoint/2010/main" val="2740231525"/>
+        <p14:creationId xmlns:p14="http://schemas.microsoft.com/office/powerpoint/2010/main" val="2125858550"/>
       </p:ext>
     </p:extLst>
   </p:cSld>
@@ -3047,7 +3115,7 @@
           <p:cNvPr id="2" name="Title Placeholder 1">
             <a:extLst>
               <a:ext uri="{FF2B5EF4-FFF2-40B4-BE49-F238E27FC236}">
-                <a16:creationId xmlns:a16="http://schemas.microsoft.com/office/drawing/2014/main" id="{25B87546-1D7E-5CC7-F41D-8196D5DEBECD}"/>
+                <a16:creationId xmlns:a16="http://schemas.microsoft.com/office/drawing/2014/main" id="{1370C4BA-D541-C05B-05F3-28C9815E3F6A}"/>
               </a:ext>
             </a:extLst>
           </p:cNvPr>
@@ -3085,7 +3153,7 @@
           <p:cNvPr id="3" name="Text Placeholder 2">
             <a:extLst>
               <a:ext uri="{FF2B5EF4-FFF2-40B4-BE49-F238E27FC236}">
-                <a16:creationId xmlns:a16="http://schemas.microsoft.com/office/drawing/2014/main" id="{A4C5092B-098F-FB34-7D40-9855F0A819B5}"/>
+                <a16:creationId xmlns:a16="http://schemas.microsoft.com/office/drawing/2014/main" id="{87D6AD4E-274C-A32F-9267-ACCF83D4C04E}"/>
               </a:ext>
             </a:extLst>
           </p:cNvPr>
@@ -3152,7 +3220,7 @@
           <p:cNvPr id="4" name="Date Placeholder 3">
             <a:extLst>
               <a:ext uri="{FF2B5EF4-FFF2-40B4-BE49-F238E27FC236}">
-                <a16:creationId xmlns:a16="http://schemas.microsoft.com/office/drawing/2014/main" id="{07189319-0285-AE39-AA75-F18CF76BC01B}"/>
+                <a16:creationId xmlns:a16="http://schemas.microsoft.com/office/drawing/2014/main" id="{703FE71A-B23E-3B6C-A24F-48D23BCD4018}"/>
               </a:ext>
             </a:extLst>
           </p:cNvPr>
@@ -3186,7 +3254,7 @@
             </a:lvl1pPr>
           </a:lstStyle>
           <a:p>
-            <a:fld id="{8257DA77-7CF4-44E1-8AD6-9D4D0A7CF6A0}" type="datetimeFigureOut">
+            <a:fld id="{918732F9-E82D-415A-A9D3-0AF6537188C2}" type="datetimeFigureOut">
               <a:rPr lang="en-US" smtClean="0"/>
               <a:t>5/27/2026</a:t>
             </a:fld>
@@ -3199,7 +3267,7 @@
           <p:cNvPr id="5" name="Footer Placeholder 4">
             <a:extLst>
               <a:ext uri="{FF2B5EF4-FFF2-40B4-BE49-F238E27FC236}">
-                <a16:creationId xmlns:a16="http://schemas.microsoft.com/office/drawing/2014/main" id="{412F28A2-0265-5663-14DC-0260F0F55995}"/>
+                <a16:creationId xmlns:a16="http://schemas.microsoft.com/office/drawing/2014/main" id="{B9FFEA23-639F-7091-DF94-299BC3E701D6}"/>
               </a:ext>
             </a:extLst>
           </p:cNvPr>
@@ -3242,7 +3310,7 @@
           <p:cNvPr id="6" name="Slide Number Placeholder 5">
             <a:extLst>
               <a:ext uri="{FF2B5EF4-FFF2-40B4-BE49-F238E27FC236}">
-                <a16:creationId xmlns:a16="http://schemas.microsoft.com/office/drawing/2014/main" id="{62D306FA-F787-A484-68E4-97B963803038}"/>
+                <a16:creationId xmlns:a16="http://schemas.microsoft.com/office/drawing/2014/main" id="{777CDFD5-4726-190A-C5BF-0942BE41B0EE}"/>
               </a:ext>
             </a:extLst>
           </p:cNvPr>
@@ -3276,7 +3344,7 @@
             </a:lvl1pPr>
           </a:lstStyle>
           <a:p>
-            <a:fld id="{B16767C5-12E3-4B50-BECE-E09F331917A2}" type="slidenum">
+            <a:fld id="{48E85829-D41B-4648-A682-E9D6673B9551}" type="slidenum">
               <a:rPr lang="en-US" smtClean="0"/>
               <a:t>‹#›</a:t>
             </a:fld>
@@ -3287,7 +3355,7 @@
     </p:spTree>
     <p:extLst>
       <p:ext uri="{BB962C8B-B14F-4D97-AF65-F5344CB8AC3E}">
-        <p14:creationId xmlns:p14="http://schemas.microsoft.com/office/powerpoint/2010/main" val="727954195"/>
+        <p14:creationId xmlns:p14="http://schemas.microsoft.com/office/powerpoint/2010/main" val="1209212381"/>
       </p:ext>
     </p:extLst>
   </p:cSld>
@@ -3610,7 +3678,7 @@
           <p:cNvPr id="2" name="Chart 1">
             <a:extLst>
               <a:ext uri="{FF2B5EF4-FFF2-40B4-BE49-F238E27FC236}">
-                <a16:creationId xmlns:a16="http://schemas.microsoft.com/office/drawing/2014/main" id="{488D329F-7C9C-9084-4490-00B94A3AD4BC}"/>
+                <a16:creationId xmlns:a16="http://schemas.microsoft.com/office/drawing/2014/main" id="{A5EE690E-D612-B462-6E42-47B5989CE7A1}"/>
               </a:ext>
             </a:extLst>
           </p:cNvPr>
@@ -3618,7 +3686,7 @@
           <p:nvPr>
             <p:extLst>
               <p:ext uri="{D42A27DB-BD31-4B8C-83A1-F6EECF244321}">
-                <p14:modId xmlns:p14="http://schemas.microsoft.com/office/powerpoint/2010/main" val="2780070204"/>
+                <p14:modId xmlns:p14="http://schemas.microsoft.com/office/powerpoint/2010/main" val="3644798115"/>
               </p:ext>
             </p:extLst>
           </p:nvPr>
@@ -3636,7 +3704,7 @@
     </p:spTree>
     <p:extLst>
       <p:ext uri="{BB962C8B-B14F-4D97-AF65-F5344CB8AC3E}">
-        <p14:creationId xmlns:p14="http://schemas.microsoft.com/office/powerpoint/2010/main" val="2799553901"/>
+        <p14:creationId xmlns:p14="http://schemas.microsoft.com/office/powerpoint/2010/main" val="1463768847"/>
       </p:ext>
     </p:extLst>
   </p:cSld>

</xml_diff>

<commit_message>
Add offset pie data label layout probe
</commit_message>
<xml_diff>
--- a/tests/Lokad.OoxPdf.Tests/Cases/pptx-ladder-11-chart-data-label-legend-keys-probe.pptx
+++ b/tests/Lokad.OoxPdf.Tests/Cases/pptx-ladder-11-chart-data-label-legend-keys-probe.pptx
@@ -230,7 +230,7 @@
           </c:val>
           <c:extLst>
             <c:ext xmlns:c16="http://schemas.microsoft.com/office/drawing/2014/chart" uri="{C3380CC4-5D6E-409C-BE32-E72D297353CC}">
-              <c16:uniqueId val="{00000000-1BA0-45C0-B7A3-DECF5B272610}"/>
+              <c16:uniqueId val="{00000000-2FD1-45DD-A0B2-1B6D43EA0785}"/>
             </c:ext>
           </c:extLst>
         </c:ser>
@@ -336,7 +336,7 @@
           </c:val>
           <c:extLst>
             <c:ext xmlns:c16="http://schemas.microsoft.com/office/drawing/2014/chart" uri="{C3380CC4-5D6E-409C-BE32-E72D297353CC}">
-              <c16:uniqueId val="{00000001-1BA0-45C0-B7A3-DECF5B272610}"/>
+              <c16:uniqueId val="{00000001-2FD1-45DD-A0B2-1B6D43EA0785}"/>
             </c:ext>
           </c:extLst>
         </c:ser>
@@ -349,11 +349,11 @@
           <c:showBubbleSize val="0"/>
         </c:dLbls>
         <c:gapWidth val="150"/>
-        <c:axId val="1320426736"/>
-        <c:axId val="1332541472"/>
+        <c:axId val="1312567615"/>
+        <c:axId val="1497686432"/>
       </c:barChart>
       <c:catAx>
-        <c:axId val="1320426736"/>
+        <c:axId val="1312567615"/>
         <c:scaling>
           <c:orientation val="minMax"/>
         </c:scaling>
@@ -380,7 +380,7 @@
             <a:endParaRPr lang="en-US"/>
           </a:p>
         </c:txPr>
-        <c:crossAx val="1332541472"/>
+        <c:crossAx val="1497686432"/>
         <c:crosses val="autoZero"/>
         <c:auto val="1"/>
         <c:lblAlgn val="ctr"/>
@@ -388,7 +388,7 @@
         <c:noMultiLvlLbl val="0"/>
       </c:catAx>
       <c:valAx>
-        <c:axId val="1332541472"/>
+        <c:axId val="1497686432"/>
         <c:scaling>
           <c:orientation val="minMax"/>
           <c:max val="14"/>
@@ -426,7 +426,7 @@
             <a:endParaRPr lang="en-US"/>
           </a:p>
         </c:txPr>
-        <c:crossAx val="1320426736"/>
+        <c:crossAx val="1312567615"/>
         <c:crosses val="autoZero"/>
         <c:crossBetween val="between"/>
         <c:majorUnit val="2"/>
@@ -481,7 +481,7 @@
           <p:cNvPr id="2" name="Title 1">
             <a:extLst>
               <a:ext uri="{FF2B5EF4-FFF2-40B4-BE49-F238E27FC236}">
-                <a16:creationId xmlns:a16="http://schemas.microsoft.com/office/drawing/2014/main" id="{25AF0409-FBDE-F5BB-38FC-8FEAAA5343F4}"/>
+                <a16:creationId xmlns:a16="http://schemas.microsoft.com/office/drawing/2014/main" id="{1919D5A9-E7E2-265F-FF37-71D0943757CD}"/>
               </a:ext>
             </a:extLst>
           </p:cNvPr>
@@ -518,7 +518,7 @@
           <p:cNvPr id="3" name="Subtitle 2">
             <a:extLst>
               <a:ext uri="{FF2B5EF4-FFF2-40B4-BE49-F238E27FC236}">
-                <a16:creationId xmlns:a16="http://schemas.microsoft.com/office/drawing/2014/main" id="{1B017BDA-B680-A8AB-8A46-18E0F552A548}"/>
+                <a16:creationId xmlns:a16="http://schemas.microsoft.com/office/drawing/2014/main" id="{04AEDCEB-4BD2-03E0-3F77-54D79AEB4B45}"/>
               </a:ext>
             </a:extLst>
           </p:cNvPr>
@@ -588,7 +588,7 @@
           <p:cNvPr id="4" name="Date Placeholder 3">
             <a:extLst>
               <a:ext uri="{FF2B5EF4-FFF2-40B4-BE49-F238E27FC236}">
-                <a16:creationId xmlns:a16="http://schemas.microsoft.com/office/drawing/2014/main" id="{5667FF8D-73CB-57C8-14D6-16C11D50875D}"/>
+                <a16:creationId xmlns:a16="http://schemas.microsoft.com/office/drawing/2014/main" id="{962BF6E1-E7D6-FF45-6ED9-17DCA8ABE0A4}"/>
               </a:ext>
             </a:extLst>
           </p:cNvPr>
@@ -604,9 +604,9 @@
           <a:bodyPr/>
           <a:lstStyle/>
           <a:p>
-            <a:fld id="{918732F9-E82D-415A-A9D3-0AF6537188C2}" type="datetimeFigureOut">
+            <a:fld id="{AA7B01AA-FD43-4AC3-AA8D-1F4CF0BBB40E}" type="datetimeFigureOut">
               <a:rPr lang="en-US" smtClean="0"/>
-              <a:t>5/27/2026</a:t>
+              <a:t>5/29/2026</a:t>
             </a:fld>
             <a:endParaRPr lang="en-US"/>
           </a:p>
@@ -617,7 +617,7 @@
           <p:cNvPr id="5" name="Footer Placeholder 4">
             <a:extLst>
               <a:ext uri="{FF2B5EF4-FFF2-40B4-BE49-F238E27FC236}">
-                <a16:creationId xmlns:a16="http://schemas.microsoft.com/office/drawing/2014/main" id="{698BC259-884E-0812-655B-402F6D444138}"/>
+                <a16:creationId xmlns:a16="http://schemas.microsoft.com/office/drawing/2014/main" id="{F48638BC-1A53-3514-1687-0A41BB5A24BD}"/>
               </a:ext>
             </a:extLst>
           </p:cNvPr>
@@ -642,7 +642,7 @@
           <p:cNvPr id="6" name="Slide Number Placeholder 5">
             <a:extLst>
               <a:ext uri="{FF2B5EF4-FFF2-40B4-BE49-F238E27FC236}">
-                <a16:creationId xmlns:a16="http://schemas.microsoft.com/office/drawing/2014/main" id="{19746E75-3055-DD1C-91B1-69898CCACEE1}"/>
+                <a16:creationId xmlns:a16="http://schemas.microsoft.com/office/drawing/2014/main" id="{1ABAA32E-1047-5EA6-D4E3-B9ABF7A4961C}"/>
               </a:ext>
             </a:extLst>
           </p:cNvPr>
@@ -658,7 +658,7 @@
           <a:bodyPr/>
           <a:lstStyle/>
           <a:p>
-            <a:fld id="{48E85829-D41B-4648-A682-E9D6673B9551}" type="slidenum">
+            <a:fld id="{FCF75339-8D65-4A28-B981-2E330DC017BD}" type="slidenum">
               <a:rPr lang="en-US" smtClean="0"/>
               <a:t>‹#›</a:t>
             </a:fld>
@@ -669,7 +669,7 @@
     </p:spTree>
     <p:extLst>
       <p:ext uri="{BB962C8B-B14F-4D97-AF65-F5344CB8AC3E}">
-        <p14:creationId xmlns:p14="http://schemas.microsoft.com/office/powerpoint/2010/main" val="3665897026"/>
+        <p14:creationId xmlns:p14="http://schemas.microsoft.com/office/powerpoint/2010/main" val="1111742355"/>
       </p:ext>
     </p:extLst>
   </p:cSld>
@@ -701,7 +701,7 @@
           <p:cNvPr id="2" name="Title 1">
             <a:extLst>
               <a:ext uri="{FF2B5EF4-FFF2-40B4-BE49-F238E27FC236}">
-                <a16:creationId xmlns:a16="http://schemas.microsoft.com/office/drawing/2014/main" id="{C97D753E-3A48-E335-DE42-3F7A7DA72203}"/>
+                <a16:creationId xmlns:a16="http://schemas.microsoft.com/office/drawing/2014/main" id="{9E24993D-DC1C-0E4A-2894-FF4A39A16A11}"/>
               </a:ext>
             </a:extLst>
           </p:cNvPr>
@@ -729,7 +729,7 @@
           <p:cNvPr id="3" name="Vertical Text Placeholder 2">
             <a:extLst>
               <a:ext uri="{FF2B5EF4-FFF2-40B4-BE49-F238E27FC236}">
-                <a16:creationId xmlns:a16="http://schemas.microsoft.com/office/drawing/2014/main" id="{317DE0D2-7297-8D74-9A1C-91BADA83521C}"/>
+                <a16:creationId xmlns:a16="http://schemas.microsoft.com/office/drawing/2014/main" id="{B073AFD8-8F01-CDF8-E433-A6E5141011F0}"/>
               </a:ext>
             </a:extLst>
           </p:cNvPr>
@@ -786,7 +786,7 @@
           <p:cNvPr id="4" name="Date Placeholder 3">
             <a:extLst>
               <a:ext uri="{FF2B5EF4-FFF2-40B4-BE49-F238E27FC236}">
-                <a16:creationId xmlns:a16="http://schemas.microsoft.com/office/drawing/2014/main" id="{B001CEDF-652E-9625-684B-F653B323C957}"/>
+                <a16:creationId xmlns:a16="http://schemas.microsoft.com/office/drawing/2014/main" id="{DF531A6B-D1A8-B972-43E2-D02861AD8ADF}"/>
               </a:ext>
             </a:extLst>
           </p:cNvPr>
@@ -802,9 +802,9 @@
           <a:bodyPr/>
           <a:lstStyle/>
           <a:p>
-            <a:fld id="{918732F9-E82D-415A-A9D3-0AF6537188C2}" type="datetimeFigureOut">
+            <a:fld id="{AA7B01AA-FD43-4AC3-AA8D-1F4CF0BBB40E}" type="datetimeFigureOut">
               <a:rPr lang="en-US" smtClean="0"/>
-              <a:t>5/27/2026</a:t>
+              <a:t>5/29/2026</a:t>
             </a:fld>
             <a:endParaRPr lang="en-US"/>
           </a:p>
@@ -815,7 +815,7 @@
           <p:cNvPr id="5" name="Footer Placeholder 4">
             <a:extLst>
               <a:ext uri="{FF2B5EF4-FFF2-40B4-BE49-F238E27FC236}">
-                <a16:creationId xmlns:a16="http://schemas.microsoft.com/office/drawing/2014/main" id="{3533222D-2B27-757C-FF2C-91CD6720BA9F}"/>
+                <a16:creationId xmlns:a16="http://schemas.microsoft.com/office/drawing/2014/main" id="{64473974-D4B5-49C5-3D68-152723E2C977}"/>
               </a:ext>
             </a:extLst>
           </p:cNvPr>
@@ -840,7 +840,7 @@
           <p:cNvPr id="6" name="Slide Number Placeholder 5">
             <a:extLst>
               <a:ext uri="{FF2B5EF4-FFF2-40B4-BE49-F238E27FC236}">
-                <a16:creationId xmlns:a16="http://schemas.microsoft.com/office/drawing/2014/main" id="{3D4C6B63-84CB-FBBC-8E45-72BAEBCF385B}"/>
+                <a16:creationId xmlns:a16="http://schemas.microsoft.com/office/drawing/2014/main" id="{8C93EF37-9E9C-AAE3-05E8-AE480640925B}"/>
               </a:ext>
             </a:extLst>
           </p:cNvPr>
@@ -856,7 +856,7 @@
           <a:bodyPr/>
           <a:lstStyle/>
           <a:p>
-            <a:fld id="{48E85829-D41B-4648-A682-E9D6673B9551}" type="slidenum">
+            <a:fld id="{FCF75339-8D65-4A28-B981-2E330DC017BD}" type="slidenum">
               <a:rPr lang="en-US" smtClean="0"/>
               <a:t>‹#›</a:t>
             </a:fld>
@@ -867,7 +867,7 @@
     </p:spTree>
     <p:extLst>
       <p:ext uri="{BB962C8B-B14F-4D97-AF65-F5344CB8AC3E}">
-        <p14:creationId xmlns:p14="http://schemas.microsoft.com/office/powerpoint/2010/main" val="879520438"/>
+        <p14:creationId xmlns:p14="http://schemas.microsoft.com/office/powerpoint/2010/main" val="2523531777"/>
       </p:ext>
     </p:extLst>
   </p:cSld>
@@ -899,7 +899,7 @@
           <p:cNvPr id="2" name="Vertical Title 1">
             <a:extLst>
               <a:ext uri="{FF2B5EF4-FFF2-40B4-BE49-F238E27FC236}">
-                <a16:creationId xmlns:a16="http://schemas.microsoft.com/office/drawing/2014/main" id="{C30039AB-B0B8-C15C-5213-0FEB14C85E26}"/>
+                <a16:creationId xmlns:a16="http://schemas.microsoft.com/office/drawing/2014/main" id="{0248ABC2-7722-CEC9-2EE3-9E1D0C3D33B7}"/>
               </a:ext>
             </a:extLst>
           </p:cNvPr>
@@ -932,7 +932,7 @@
           <p:cNvPr id="3" name="Vertical Text Placeholder 2">
             <a:extLst>
               <a:ext uri="{FF2B5EF4-FFF2-40B4-BE49-F238E27FC236}">
-                <a16:creationId xmlns:a16="http://schemas.microsoft.com/office/drawing/2014/main" id="{9E500F20-15DF-F877-70D4-06E22B0DE9FB}"/>
+                <a16:creationId xmlns:a16="http://schemas.microsoft.com/office/drawing/2014/main" id="{37C5E2F6-9FDE-A9C5-8579-DA911C9B980E}"/>
               </a:ext>
             </a:extLst>
           </p:cNvPr>
@@ -994,7 +994,7 @@
           <p:cNvPr id="4" name="Date Placeholder 3">
             <a:extLst>
               <a:ext uri="{FF2B5EF4-FFF2-40B4-BE49-F238E27FC236}">
-                <a16:creationId xmlns:a16="http://schemas.microsoft.com/office/drawing/2014/main" id="{E0414496-A281-D790-CE77-02212136169F}"/>
+                <a16:creationId xmlns:a16="http://schemas.microsoft.com/office/drawing/2014/main" id="{3585396F-D91B-6444-9383-0424967DE241}"/>
               </a:ext>
             </a:extLst>
           </p:cNvPr>
@@ -1010,9 +1010,9 @@
           <a:bodyPr/>
           <a:lstStyle/>
           <a:p>
-            <a:fld id="{918732F9-E82D-415A-A9D3-0AF6537188C2}" type="datetimeFigureOut">
+            <a:fld id="{AA7B01AA-FD43-4AC3-AA8D-1F4CF0BBB40E}" type="datetimeFigureOut">
               <a:rPr lang="en-US" smtClean="0"/>
-              <a:t>5/27/2026</a:t>
+              <a:t>5/29/2026</a:t>
             </a:fld>
             <a:endParaRPr lang="en-US"/>
           </a:p>
@@ -1023,7 +1023,7 @@
           <p:cNvPr id="5" name="Footer Placeholder 4">
             <a:extLst>
               <a:ext uri="{FF2B5EF4-FFF2-40B4-BE49-F238E27FC236}">
-                <a16:creationId xmlns:a16="http://schemas.microsoft.com/office/drawing/2014/main" id="{90025632-FE7F-CB0B-5E28-30D1A67F8547}"/>
+                <a16:creationId xmlns:a16="http://schemas.microsoft.com/office/drawing/2014/main" id="{8B043C4E-D6C3-98D9-A2FD-6067741A599C}"/>
               </a:ext>
             </a:extLst>
           </p:cNvPr>
@@ -1048,7 +1048,7 @@
           <p:cNvPr id="6" name="Slide Number Placeholder 5">
             <a:extLst>
               <a:ext uri="{FF2B5EF4-FFF2-40B4-BE49-F238E27FC236}">
-                <a16:creationId xmlns:a16="http://schemas.microsoft.com/office/drawing/2014/main" id="{B1CBC361-A34D-D312-C355-7D3D09FD8258}"/>
+                <a16:creationId xmlns:a16="http://schemas.microsoft.com/office/drawing/2014/main" id="{3B66C7E5-77A6-B892-B29F-9A8AD41EA209}"/>
               </a:ext>
             </a:extLst>
           </p:cNvPr>
@@ -1064,7 +1064,7 @@
           <a:bodyPr/>
           <a:lstStyle/>
           <a:p>
-            <a:fld id="{48E85829-D41B-4648-A682-E9D6673B9551}" type="slidenum">
+            <a:fld id="{FCF75339-8D65-4A28-B981-2E330DC017BD}" type="slidenum">
               <a:rPr lang="en-US" smtClean="0"/>
               <a:t>‹#›</a:t>
             </a:fld>
@@ -1075,7 +1075,7 @@
     </p:spTree>
     <p:extLst>
       <p:ext uri="{BB962C8B-B14F-4D97-AF65-F5344CB8AC3E}">
-        <p14:creationId xmlns:p14="http://schemas.microsoft.com/office/powerpoint/2010/main" val="3954207604"/>
+        <p14:creationId xmlns:p14="http://schemas.microsoft.com/office/powerpoint/2010/main" val="54399622"/>
       </p:ext>
     </p:extLst>
   </p:cSld>
@@ -1107,7 +1107,7 @@
           <p:cNvPr id="2" name="Title 1">
             <a:extLst>
               <a:ext uri="{FF2B5EF4-FFF2-40B4-BE49-F238E27FC236}">
-                <a16:creationId xmlns:a16="http://schemas.microsoft.com/office/drawing/2014/main" id="{3A87E68A-D60C-96D5-6AD7-88428D492EE9}"/>
+                <a16:creationId xmlns:a16="http://schemas.microsoft.com/office/drawing/2014/main" id="{C41891F9-A71E-7567-8121-E6558EA71164}"/>
               </a:ext>
             </a:extLst>
           </p:cNvPr>
@@ -1135,7 +1135,7 @@
           <p:cNvPr id="3" name="Content Placeholder 2">
             <a:extLst>
               <a:ext uri="{FF2B5EF4-FFF2-40B4-BE49-F238E27FC236}">
-                <a16:creationId xmlns:a16="http://schemas.microsoft.com/office/drawing/2014/main" id="{2215DB14-98F9-148B-F954-527C54B8211B}"/>
+                <a16:creationId xmlns:a16="http://schemas.microsoft.com/office/drawing/2014/main" id="{662E7D9B-471F-A05D-7C77-08F334FCF517}"/>
               </a:ext>
             </a:extLst>
           </p:cNvPr>
@@ -1192,7 +1192,7 @@
           <p:cNvPr id="4" name="Date Placeholder 3">
             <a:extLst>
               <a:ext uri="{FF2B5EF4-FFF2-40B4-BE49-F238E27FC236}">
-                <a16:creationId xmlns:a16="http://schemas.microsoft.com/office/drawing/2014/main" id="{C9B757C4-86B7-4F08-B380-13380D44F32D}"/>
+                <a16:creationId xmlns:a16="http://schemas.microsoft.com/office/drawing/2014/main" id="{4CE0CAC1-5976-3EA4-D6C9-9529A39FEDBA}"/>
               </a:ext>
             </a:extLst>
           </p:cNvPr>
@@ -1208,9 +1208,9 @@
           <a:bodyPr/>
           <a:lstStyle/>
           <a:p>
-            <a:fld id="{918732F9-E82D-415A-A9D3-0AF6537188C2}" type="datetimeFigureOut">
+            <a:fld id="{AA7B01AA-FD43-4AC3-AA8D-1F4CF0BBB40E}" type="datetimeFigureOut">
               <a:rPr lang="en-US" smtClean="0"/>
-              <a:t>5/27/2026</a:t>
+              <a:t>5/29/2026</a:t>
             </a:fld>
             <a:endParaRPr lang="en-US"/>
           </a:p>
@@ -1221,7 +1221,7 @@
           <p:cNvPr id="5" name="Footer Placeholder 4">
             <a:extLst>
               <a:ext uri="{FF2B5EF4-FFF2-40B4-BE49-F238E27FC236}">
-                <a16:creationId xmlns:a16="http://schemas.microsoft.com/office/drawing/2014/main" id="{6B375508-FD6C-83EC-EDBA-C277FB027205}"/>
+                <a16:creationId xmlns:a16="http://schemas.microsoft.com/office/drawing/2014/main" id="{FDB58B99-B791-3D03-CA28-8AA176E6FD0D}"/>
               </a:ext>
             </a:extLst>
           </p:cNvPr>
@@ -1246,7 +1246,7 @@
           <p:cNvPr id="6" name="Slide Number Placeholder 5">
             <a:extLst>
               <a:ext uri="{FF2B5EF4-FFF2-40B4-BE49-F238E27FC236}">
-                <a16:creationId xmlns:a16="http://schemas.microsoft.com/office/drawing/2014/main" id="{9C255B61-17A3-E0ED-9256-237746758220}"/>
+                <a16:creationId xmlns:a16="http://schemas.microsoft.com/office/drawing/2014/main" id="{C61B530C-D5DD-FE59-7407-7861F0EB2B77}"/>
               </a:ext>
             </a:extLst>
           </p:cNvPr>
@@ -1262,7 +1262,7 @@
           <a:bodyPr/>
           <a:lstStyle/>
           <a:p>
-            <a:fld id="{48E85829-D41B-4648-A682-E9D6673B9551}" type="slidenum">
+            <a:fld id="{FCF75339-8D65-4A28-B981-2E330DC017BD}" type="slidenum">
               <a:rPr lang="en-US" smtClean="0"/>
               <a:t>‹#›</a:t>
             </a:fld>
@@ -1273,7 +1273,7 @@
     </p:spTree>
     <p:extLst>
       <p:ext uri="{BB962C8B-B14F-4D97-AF65-F5344CB8AC3E}">
-        <p14:creationId xmlns:p14="http://schemas.microsoft.com/office/powerpoint/2010/main" val="980644156"/>
+        <p14:creationId xmlns:p14="http://schemas.microsoft.com/office/powerpoint/2010/main" val="1946087439"/>
       </p:ext>
     </p:extLst>
   </p:cSld>
@@ -1305,7 +1305,7 @@
           <p:cNvPr id="2" name="Title 1">
             <a:extLst>
               <a:ext uri="{FF2B5EF4-FFF2-40B4-BE49-F238E27FC236}">
-                <a16:creationId xmlns:a16="http://schemas.microsoft.com/office/drawing/2014/main" id="{9719443C-AC61-726A-DF8D-04DC1859FA14}"/>
+                <a16:creationId xmlns:a16="http://schemas.microsoft.com/office/drawing/2014/main" id="{D8CA5761-D829-A28E-C238-A1A54357B857}"/>
               </a:ext>
             </a:extLst>
           </p:cNvPr>
@@ -1342,7 +1342,7 @@
           <p:cNvPr id="3" name="Text Placeholder 2">
             <a:extLst>
               <a:ext uri="{FF2B5EF4-FFF2-40B4-BE49-F238E27FC236}">
-                <a16:creationId xmlns:a16="http://schemas.microsoft.com/office/drawing/2014/main" id="{38BDF1EE-9DD5-468D-48B2-4F5239BFBA3C}"/>
+                <a16:creationId xmlns:a16="http://schemas.microsoft.com/office/drawing/2014/main" id="{B39B1805-AF34-D0EF-2C8B-DFE994A67F01}"/>
               </a:ext>
             </a:extLst>
           </p:cNvPr>
@@ -1467,7 +1467,7 @@
           <p:cNvPr id="4" name="Date Placeholder 3">
             <a:extLst>
               <a:ext uri="{FF2B5EF4-FFF2-40B4-BE49-F238E27FC236}">
-                <a16:creationId xmlns:a16="http://schemas.microsoft.com/office/drawing/2014/main" id="{83C136F3-0250-61BC-BD36-DC56E9D980EB}"/>
+                <a16:creationId xmlns:a16="http://schemas.microsoft.com/office/drawing/2014/main" id="{F3995B6B-CCAA-2824-D6A6-D2E8F81BBAAF}"/>
               </a:ext>
             </a:extLst>
           </p:cNvPr>
@@ -1483,9 +1483,9 @@
           <a:bodyPr/>
           <a:lstStyle/>
           <a:p>
-            <a:fld id="{918732F9-E82D-415A-A9D3-0AF6537188C2}" type="datetimeFigureOut">
+            <a:fld id="{AA7B01AA-FD43-4AC3-AA8D-1F4CF0BBB40E}" type="datetimeFigureOut">
               <a:rPr lang="en-US" smtClean="0"/>
-              <a:t>5/27/2026</a:t>
+              <a:t>5/29/2026</a:t>
             </a:fld>
             <a:endParaRPr lang="en-US"/>
           </a:p>
@@ -1496,7 +1496,7 @@
           <p:cNvPr id="5" name="Footer Placeholder 4">
             <a:extLst>
               <a:ext uri="{FF2B5EF4-FFF2-40B4-BE49-F238E27FC236}">
-                <a16:creationId xmlns:a16="http://schemas.microsoft.com/office/drawing/2014/main" id="{117ECDD2-F73E-D874-8A2E-824305E1A130}"/>
+                <a16:creationId xmlns:a16="http://schemas.microsoft.com/office/drawing/2014/main" id="{E495B10C-F606-4771-C646-7C8EE6F4A4CE}"/>
               </a:ext>
             </a:extLst>
           </p:cNvPr>
@@ -1521,7 +1521,7 @@
           <p:cNvPr id="6" name="Slide Number Placeholder 5">
             <a:extLst>
               <a:ext uri="{FF2B5EF4-FFF2-40B4-BE49-F238E27FC236}">
-                <a16:creationId xmlns:a16="http://schemas.microsoft.com/office/drawing/2014/main" id="{910BADF6-6D5C-EA72-9DF0-5DCA72E8BD80}"/>
+                <a16:creationId xmlns:a16="http://schemas.microsoft.com/office/drawing/2014/main" id="{5C8DE29C-F9F7-111D-9F87-5B0694D82745}"/>
               </a:ext>
             </a:extLst>
           </p:cNvPr>
@@ -1537,7 +1537,7 @@
           <a:bodyPr/>
           <a:lstStyle/>
           <a:p>
-            <a:fld id="{48E85829-D41B-4648-A682-E9D6673B9551}" type="slidenum">
+            <a:fld id="{FCF75339-8D65-4A28-B981-2E330DC017BD}" type="slidenum">
               <a:rPr lang="en-US" smtClean="0"/>
               <a:t>‹#›</a:t>
             </a:fld>
@@ -1548,7 +1548,7 @@
     </p:spTree>
     <p:extLst>
       <p:ext uri="{BB962C8B-B14F-4D97-AF65-F5344CB8AC3E}">
-        <p14:creationId xmlns:p14="http://schemas.microsoft.com/office/powerpoint/2010/main" val="2744490245"/>
+        <p14:creationId xmlns:p14="http://schemas.microsoft.com/office/powerpoint/2010/main" val="1146550677"/>
       </p:ext>
     </p:extLst>
   </p:cSld>
@@ -1580,7 +1580,7 @@
           <p:cNvPr id="2" name="Title 1">
             <a:extLst>
               <a:ext uri="{FF2B5EF4-FFF2-40B4-BE49-F238E27FC236}">
-                <a16:creationId xmlns:a16="http://schemas.microsoft.com/office/drawing/2014/main" id="{B9361047-25AA-E43E-3578-1E7CF3C6AF33}"/>
+                <a16:creationId xmlns:a16="http://schemas.microsoft.com/office/drawing/2014/main" id="{7800ECB6-E09D-5E2A-801F-06E496E6F305}"/>
               </a:ext>
             </a:extLst>
           </p:cNvPr>
@@ -1608,7 +1608,7 @@
           <p:cNvPr id="3" name="Content Placeholder 2">
             <a:extLst>
               <a:ext uri="{FF2B5EF4-FFF2-40B4-BE49-F238E27FC236}">
-                <a16:creationId xmlns:a16="http://schemas.microsoft.com/office/drawing/2014/main" id="{EDBB14E9-99BE-B79E-24D1-0DB714CF74F2}"/>
+                <a16:creationId xmlns:a16="http://schemas.microsoft.com/office/drawing/2014/main" id="{89A815A6-6455-078E-8D91-D3652CBDE073}"/>
               </a:ext>
             </a:extLst>
           </p:cNvPr>
@@ -1670,7 +1670,7 @@
           <p:cNvPr id="4" name="Content Placeholder 3">
             <a:extLst>
               <a:ext uri="{FF2B5EF4-FFF2-40B4-BE49-F238E27FC236}">
-                <a16:creationId xmlns:a16="http://schemas.microsoft.com/office/drawing/2014/main" id="{1F85D0CE-78B9-31E0-9243-BAEC6716766C}"/>
+                <a16:creationId xmlns:a16="http://schemas.microsoft.com/office/drawing/2014/main" id="{63EEB97C-F4C2-609B-5933-BF18AF090231}"/>
               </a:ext>
             </a:extLst>
           </p:cNvPr>
@@ -1732,7 +1732,7 @@
           <p:cNvPr id="5" name="Date Placeholder 4">
             <a:extLst>
               <a:ext uri="{FF2B5EF4-FFF2-40B4-BE49-F238E27FC236}">
-                <a16:creationId xmlns:a16="http://schemas.microsoft.com/office/drawing/2014/main" id="{186A7C3D-B8C9-52C7-8E48-FFF97EE2EBAE}"/>
+                <a16:creationId xmlns:a16="http://schemas.microsoft.com/office/drawing/2014/main" id="{7F12964F-FAD9-C693-54FF-B2E12B495F9A}"/>
               </a:ext>
             </a:extLst>
           </p:cNvPr>
@@ -1748,9 +1748,9 @@
           <a:bodyPr/>
           <a:lstStyle/>
           <a:p>
-            <a:fld id="{918732F9-E82D-415A-A9D3-0AF6537188C2}" type="datetimeFigureOut">
+            <a:fld id="{AA7B01AA-FD43-4AC3-AA8D-1F4CF0BBB40E}" type="datetimeFigureOut">
               <a:rPr lang="en-US" smtClean="0"/>
-              <a:t>5/27/2026</a:t>
+              <a:t>5/29/2026</a:t>
             </a:fld>
             <a:endParaRPr lang="en-US"/>
           </a:p>
@@ -1761,7 +1761,7 @@
           <p:cNvPr id="6" name="Footer Placeholder 5">
             <a:extLst>
               <a:ext uri="{FF2B5EF4-FFF2-40B4-BE49-F238E27FC236}">
-                <a16:creationId xmlns:a16="http://schemas.microsoft.com/office/drawing/2014/main" id="{E620632B-265F-0633-1F90-09A30B3EFB34}"/>
+                <a16:creationId xmlns:a16="http://schemas.microsoft.com/office/drawing/2014/main" id="{F87ADCE7-294C-4FF7-637E-87FA225BF184}"/>
               </a:ext>
             </a:extLst>
           </p:cNvPr>
@@ -1786,7 +1786,7 @@
           <p:cNvPr id="7" name="Slide Number Placeholder 6">
             <a:extLst>
               <a:ext uri="{FF2B5EF4-FFF2-40B4-BE49-F238E27FC236}">
-                <a16:creationId xmlns:a16="http://schemas.microsoft.com/office/drawing/2014/main" id="{CBBCE58E-C3C8-D4D1-1B28-D78FA0AFF101}"/>
+                <a16:creationId xmlns:a16="http://schemas.microsoft.com/office/drawing/2014/main" id="{0C42F428-2CAE-9A34-7B6C-3CEFFC5CB776}"/>
               </a:ext>
             </a:extLst>
           </p:cNvPr>
@@ -1802,7 +1802,7 @@
           <a:bodyPr/>
           <a:lstStyle/>
           <a:p>
-            <a:fld id="{48E85829-D41B-4648-A682-E9D6673B9551}" type="slidenum">
+            <a:fld id="{FCF75339-8D65-4A28-B981-2E330DC017BD}" type="slidenum">
               <a:rPr lang="en-US" smtClean="0"/>
               <a:t>‹#›</a:t>
             </a:fld>
@@ -1813,7 +1813,7 @@
     </p:spTree>
     <p:extLst>
       <p:ext uri="{BB962C8B-B14F-4D97-AF65-F5344CB8AC3E}">
-        <p14:creationId xmlns:p14="http://schemas.microsoft.com/office/powerpoint/2010/main" val="1666523815"/>
+        <p14:creationId xmlns:p14="http://schemas.microsoft.com/office/powerpoint/2010/main" val="3985582693"/>
       </p:ext>
     </p:extLst>
   </p:cSld>
@@ -1845,7 +1845,7 @@
           <p:cNvPr id="2" name="Title 1">
             <a:extLst>
               <a:ext uri="{FF2B5EF4-FFF2-40B4-BE49-F238E27FC236}">
-                <a16:creationId xmlns:a16="http://schemas.microsoft.com/office/drawing/2014/main" id="{2F1D7975-49F5-BAFB-03E5-3FDEC36A17FA}"/>
+                <a16:creationId xmlns:a16="http://schemas.microsoft.com/office/drawing/2014/main" id="{86CF26DE-D0E1-3882-A6EC-3A9711E35970}"/>
               </a:ext>
             </a:extLst>
           </p:cNvPr>
@@ -1878,7 +1878,7 @@
           <p:cNvPr id="3" name="Text Placeholder 2">
             <a:extLst>
               <a:ext uri="{FF2B5EF4-FFF2-40B4-BE49-F238E27FC236}">
-                <a16:creationId xmlns:a16="http://schemas.microsoft.com/office/drawing/2014/main" id="{E7307A45-8B24-E221-46FA-478A70F0CC2D}"/>
+                <a16:creationId xmlns:a16="http://schemas.microsoft.com/office/drawing/2014/main" id="{5EA392D8-889C-E386-5DCE-C331AFC14F7C}"/>
               </a:ext>
             </a:extLst>
           </p:cNvPr>
@@ -1949,7 +1949,7 @@
           <p:cNvPr id="4" name="Content Placeholder 3">
             <a:extLst>
               <a:ext uri="{FF2B5EF4-FFF2-40B4-BE49-F238E27FC236}">
-                <a16:creationId xmlns:a16="http://schemas.microsoft.com/office/drawing/2014/main" id="{82AA3F0A-4D61-D52D-D8B6-336C5A700DB4}"/>
+                <a16:creationId xmlns:a16="http://schemas.microsoft.com/office/drawing/2014/main" id="{A987A17B-438E-4016-990A-82E0D8B28458}"/>
               </a:ext>
             </a:extLst>
           </p:cNvPr>
@@ -2011,7 +2011,7 @@
           <p:cNvPr id="5" name="Text Placeholder 4">
             <a:extLst>
               <a:ext uri="{FF2B5EF4-FFF2-40B4-BE49-F238E27FC236}">
-                <a16:creationId xmlns:a16="http://schemas.microsoft.com/office/drawing/2014/main" id="{04BBDBB5-1181-81B7-85AF-611D3DF49D45}"/>
+                <a16:creationId xmlns:a16="http://schemas.microsoft.com/office/drawing/2014/main" id="{F0C78BE9-97AB-E430-EAE5-CC3523D0F0EF}"/>
               </a:ext>
             </a:extLst>
           </p:cNvPr>
@@ -2082,7 +2082,7 @@
           <p:cNvPr id="6" name="Content Placeholder 5">
             <a:extLst>
               <a:ext uri="{FF2B5EF4-FFF2-40B4-BE49-F238E27FC236}">
-                <a16:creationId xmlns:a16="http://schemas.microsoft.com/office/drawing/2014/main" id="{512F0A7C-811D-6C9A-4882-62BC54A99B66}"/>
+                <a16:creationId xmlns:a16="http://schemas.microsoft.com/office/drawing/2014/main" id="{8300000B-B830-CC4F-7C71-189370A0C099}"/>
               </a:ext>
             </a:extLst>
           </p:cNvPr>
@@ -2144,7 +2144,7 @@
           <p:cNvPr id="7" name="Date Placeholder 6">
             <a:extLst>
               <a:ext uri="{FF2B5EF4-FFF2-40B4-BE49-F238E27FC236}">
-                <a16:creationId xmlns:a16="http://schemas.microsoft.com/office/drawing/2014/main" id="{8B13A1E1-5CCD-0678-9218-385EEC8F8F88}"/>
+                <a16:creationId xmlns:a16="http://schemas.microsoft.com/office/drawing/2014/main" id="{80A11E64-0F1E-A505-10AC-7A4E08DCEA35}"/>
               </a:ext>
             </a:extLst>
           </p:cNvPr>
@@ -2160,9 +2160,9 @@
           <a:bodyPr/>
           <a:lstStyle/>
           <a:p>
-            <a:fld id="{918732F9-E82D-415A-A9D3-0AF6537188C2}" type="datetimeFigureOut">
+            <a:fld id="{AA7B01AA-FD43-4AC3-AA8D-1F4CF0BBB40E}" type="datetimeFigureOut">
               <a:rPr lang="en-US" smtClean="0"/>
-              <a:t>5/27/2026</a:t>
+              <a:t>5/29/2026</a:t>
             </a:fld>
             <a:endParaRPr lang="en-US"/>
           </a:p>
@@ -2173,7 +2173,7 @@
           <p:cNvPr id="8" name="Footer Placeholder 7">
             <a:extLst>
               <a:ext uri="{FF2B5EF4-FFF2-40B4-BE49-F238E27FC236}">
-                <a16:creationId xmlns:a16="http://schemas.microsoft.com/office/drawing/2014/main" id="{FA9F6E62-21A1-A6BF-581C-5B6E32C28535}"/>
+                <a16:creationId xmlns:a16="http://schemas.microsoft.com/office/drawing/2014/main" id="{9E11581E-2730-D918-ACB4-F334C2EA38F4}"/>
               </a:ext>
             </a:extLst>
           </p:cNvPr>
@@ -2198,7 +2198,7 @@
           <p:cNvPr id="9" name="Slide Number Placeholder 8">
             <a:extLst>
               <a:ext uri="{FF2B5EF4-FFF2-40B4-BE49-F238E27FC236}">
-                <a16:creationId xmlns:a16="http://schemas.microsoft.com/office/drawing/2014/main" id="{B9D4DADD-C31E-F589-AD72-69446EFCD01A}"/>
+                <a16:creationId xmlns:a16="http://schemas.microsoft.com/office/drawing/2014/main" id="{9B75C094-2695-2DB8-99F1-DA5B875A2CAF}"/>
               </a:ext>
             </a:extLst>
           </p:cNvPr>
@@ -2214,7 +2214,7 @@
           <a:bodyPr/>
           <a:lstStyle/>
           <a:p>
-            <a:fld id="{48E85829-D41B-4648-A682-E9D6673B9551}" type="slidenum">
+            <a:fld id="{FCF75339-8D65-4A28-B981-2E330DC017BD}" type="slidenum">
               <a:rPr lang="en-US" smtClean="0"/>
               <a:t>‹#›</a:t>
             </a:fld>
@@ -2225,7 +2225,7 @@
     </p:spTree>
     <p:extLst>
       <p:ext uri="{BB962C8B-B14F-4D97-AF65-F5344CB8AC3E}">
-        <p14:creationId xmlns:p14="http://schemas.microsoft.com/office/powerpoint/2010/main" val="49812956"/>
+        <p14:creationId xmlns:p14="http://schemas.microsoft.com/office/powerpoint/2010/main" val="2624812942"/>
       </p:ext>
     </p:extLst>
   </p:cSld>
@@ -2257,7 +2257,7 @@
           <p:cNvPr id="2" name="Title 1">
             <a:extLst>
               <a:ext uri="{FF2B5EF4-FFF2-40B4-BE49-F238E27FC236}">
-                <a16:creationId xmlns:a16="http://schemas.microsoft.com/office/drawing/2014/main" id="{9E131549-C570-C000-EB6C-9C73945C36C4}"/>
+                <a16:creationId xmlns:a16="http://schemas.microsoft.com/office/drawing/2014/main" id="{CCACE7A2-3B4F-2998-01BD-6DE3EEDF1B06}"/>
               </a:ext>
             </a:extLst>
           </p:cNvPr>
@@ -2285,7 +2285,7 @@
           <p:cNvPr id="3" name="Date Placeholder 2">
             <a:extLst>
               <a:ext uri="{FF2B5EF4-FFF2-40B4-BE49-F238E27FC236}">
-                <a16:creationId xmlns:a16="http://schemas.microsoft.com/office/drawing/2014/main" id="{2EDECF09-BF57-57E3-5807-FF0DEA6C03B8}"/>
+                <a16:creationId xmlns:a16="http://schemas.microsoft.com/office/drawing/2014/main" id="{08BCBEB7-2B6E-3CFB-1836-F904F65E0693}"/>
               </a:ext>
             </a:extLst>
           </p:cNvPr>
@@ -2301,9 +2301,9 @@
           <a:bodyPr/>
           <a:lstStyle/>
           <a:p>
-            <a:fld id="{918732F9-E82D-415A-A9D3-0AF6537188C2}" type="datetimeFigureOut">
+            <a:fld id="{AA7B01AA-FD43-4AC3-AA8D-1F4CF0BBB40E}" type="datetimeFigureOut">
               <a:rPr lang="en-US" smtClean="0"/>
-              <a:t>5/27/2026</a:t>
+              <a:t>5/29/2026</a:t>
             </a:fld>
             <a:endParaRPr lang="en-US"/>
           </a:p>
@@ -2314,7 +2314,7 @@
           <p:cNvPr id="4" name="Footer Placeholder 3">
             <a:extLst>
               <a:ext uri="{FF2B5EF4-FFF2-40B4-BE49-F238E27FC236}">
-                <a16:creationId xmlns:a16="http://schemas.microsoft.com/office/drawing/2014/main" id="{F5C5B8E5-D663-AD1E-360A-B890BC95A3F2}"/>
+                <a16:creationId xmlns:a16="http://schemas.microsoft.com/office/drawing/2014/main" id="{E9ED5FB7-9400-EE3A-58C7-1E34123A0CA1}"/>
               </a:ext>
             </a:extLst>
           </p:cNvPr>
@@ -2339,7 +2339,7 @@
           <p:cNvPr id="5" name="Slide Number Placeholder 4">
             <a:extLst>
               <a:ext uri="{FF2B5EF4-FFF2-40B4-BE49-F238E27FC236}">
-                <a16:creationId xmlns:a16="http://schemas.microsoft.com/office/drawing/2014/main" id="{5F35D764-984F-A8E1-14E4-264F3FCF07F5}"/>
+                <a16:creationId xmlns:a16="http://schemas.microsoft.com/office/drawing/2014/main" id="{7894FB00-F355-7BD2-D101-458B791DC4F8}"/>
               </a:ext>
             </a:extLst>
           </p:cNvPr>
@@ -2355,7 +2355,7 @@
           <a:bodyPr/>
           <a:lstStyle/>
           <a:p>
-            <a:fld id="{48E85829-D41B-4648-A682-E9D6673B9551}" type="slidenum">
+            <a:fld id="{FCF75339-8D65-4A28-B981-2E330DC017BD}" type="slidenum">
               <a:rPr lang="en-US" smtClean="0"/>
               <a:t>‹#›</a:t>
             </a:fld>
@@ -2366,7 +2366,7 @@
     </p:spTree>
     <p:extLst>
       <p:ext uri="{BB962C8B-B14F-4D97-AF65-F5344CB8AC3E}">
-        <p14:creationId xmlns:p14="http://schemas.microsoft.com/office/powerpoint/2010/main" val="2609184926"/>
+        <p14:creationId xmlns:p14="http://schemas.microsoft.com/office/powerpoint/2010/main" val="1849137836"/>
       </p:ext>
     </p:extLst>
   </p:cSld>
@@ -2398,7 +2398,7 @@
           <p:cNvPr id="2" name="Date Placeholder 1">
             <a:extLst>
               <a:ext uri="{FF2B5EF4-FFF2-40B4-BE49-F238E27FC236}">
-                <a16:creationId xmlns:a16="http://schemas.microsoft.com/office/drawing/2014/main" id="{3D2590D1-FE27-FF61-2756-A3FE0D50AAFF}"/>
+                <a16:creationId xmlns:a16="http://schemas.microsoft.com/office/drawing/2014/main" id="{262282C1-92C1-7D8A-B949-14185FB0DECC}"/>
               </a:ext>
             </a:extLst>
           </p:cNvPr>
@@ -2414,9 +2414,9 @@
           <a:bodyPr/>
           <a:lstStyle/>
           <a:p>
-            <a:fld id="{918732F9-E82D-415A-A9D3-0AF6537188C2}" type="datetimeFigureOut">
+            <a:fld id="{AA7B01AA-FD43-4AC3-AA8D-1F4CF0BBB40E}" type="datetimeFigureOut">
               <a:rPr lang="en-US" smtClean="0"/>
-              <a:t>5/27/2026</a:t>
+              <a:t>5/29/2026</a:t>
             </a:fld>
             <a:endParaRPr lang="en-US"/>
           </a:p>
@@ -2427,7 +2427,7 @@
           <p:cNvPr id="3" name="Footer Placeholder 2">
             <a:extLst>
               <a:ext uri="{FF2B5EF4-FFF2-40B4-BE49-F238E27FC236}">
-                <a16:creationId xmlns:a16="http://schemas.microsoft.com/office/drawing/2014/main" id="{5693B237-FB22-C3D3-BEF7-77A991DFC854}"/>
+                <a16:creationId xmlns:a16="http://schemas.microsoft.com/office/drawing/2014/main" id="{7F0054AE-70FD-9335-7F96-48A551FCD096}"/>
               </a:ext>
             </a:extLst>
           </p:cNvPr>
@@ -2452,7 +2452,7 @@
           <p:cNvPr id="4" name="Slide Number Placeholder 3">
             <a:extLst>
               <a:ext uri="{FF2B5EF4-FFF2-40B4-BE49-F238E27FC236}">
-                <a16:creationId xmlns:a16="http://schemas.microsoft.com/office/drawing/2014/main" id="{610163F4-DD41-6354-878E-081F44C51F91}"/>
+                <a16:creationId xmlns:a16="http://schemas.microsoft.com/office/drawing/2014/main" id="{E28ABFA6-80BE-7AEC-6520-6A26B685FBF4}"/>
               </a:ext>
             </a:extLst>
           </p:cNvPr>
@@ -2468,7 +2468,7 @@
           <a:bodyPr/>
           <a:lstStyle/>
           <a:p>
-            <a:fld id="{48E85829-D41B-4648-A682-E9D6673B9551}" type="slidenum">
+            <a:fld id="{FCF75339-8D65-4A28-B981-2E330DC017BD}" type="slidenum">
               <a:rPr lang="en-US" smtClean="0"/>
               <a:t>‹#›</a:t>
             </a:fld>
@@ -2479,7 +2479,7 @@
     </p:spTree>
     <p:extLst>
       <p:ext uri="{BB962C8B-B14F-4D97-AF65-F5344CB8AC3E}">
-        <p14:creationId xmlns:p14="http://schemas.microsoft.com/office/powerpoint/2010/main" val="903044666"/>
+        <p14:creationId xmlns:p14="http://schemas.microsoft.com/office/powerpoint/2010/main" val="2789704700"/>
       </p:ext>
     </p:extLst>
   </p:cSld>
@@ -2511,7 +2511,7 @@
           <p:cNvPr id="2" name="Title 1">
             <a:extLst>
               <a:ext uri="{FF2B5EF4-FFF2-40B4-BE49-F238E27FC236}">
-                <a16:creationId xmlns:a16="http://schemas.microsoft.com/office/drawing/2014/main" id="{73FD3186-CCEE-E66F-F12F-C000D408BF48}"/>
+                <a16:creationId xmlns:a16="http://schemas.microsoft.com/office/drawing/2014/main" id="{9E667180-1A2E-8EF3-9282-067E6F63BDB0}"/>
               </a:ext>
             </a:extLst>
           </p:cNvPr>
@@ -2548,7 +2548,7 @@
           <p:cNvPr id="3" name="Content Placeholder 2">
             <a:extLst>
               <a:ext uri="{FF2B5EF4-FFF2-40B4-BE49-F238E27FC236}">
-                <a16:creationId xmlns:a16="http://schemas.microsoft.com/office/drawing/2014/main" id="{AEECFDF7-7955-C71F-5953-12152519F842}"/>
+                <a16:creationId xmlns:a16="http://schemas.microsoft.com/office/drawing/2014/main" id="{2639AAD0-64DD-686E-BFBA-4E7E99A98EBC}"/>
               </a:ext>
             </a:extLst>
           </p:cNvPr>
@@ -2638,7 +2638,7 @@
           <p:cNvPr id="4" name="Text Placeholder 3">
             <a:extLst>
               <a:ext uri="{FF2B5EF4-FFF2-40B4-BE49-F238E27FC236}">
-                <a16:creationId xmlns:a16="http://schemas.microsoft.com/office/drawing/2014/main" id="{C00A42DA-65C5-D303-F56B-25BB20094F7C}"/>
+                <a16:creationId xmlns:a16="http://schemas.microsoft.com/office/drawing/2014/main" id="{64C866E0-19EB-99DF-EAA4-F9DD3B664C3D}"/>
               </a:ext>
             </a:extLst>
           </p:cNvPr>
@@ -2709,7 +2709,7 @@
           <p:cNvPr id="5" name="Date Placeholder 4">
             <a:extLst>
               <a:ext uri="{FF2B5EF4-FFF2-40B4-BE49-F238E27FC236}">
-                <a16:creationId xmlns:a16="http://schemas.microsoft.com/office/drawing/2014/main" id="{3BC20096-F78B-8167-1B3D-FC1DC5607C65}"/>
+                <a16:creationId xmlns:a16="http://schemas.microsoft.com/office/drawing/2014/main" id="{7C01D22A-AFBC-0833-B3ED-4AC22D0C31B4}"/>
               </a:ext>
             </a:extLst>
           </p:cNvPr>
@@ -2725,9 +2725,9 @@
           <a:bodyPr/>
           <a:lstStyle/>
           <a:p>
-            <a:fld id="{918732F9-E82D-415A-A9D3-0AF6537188C2}" type="datetimeFigureOut">
+            <a:fld id="{AA7B01AA-FD43-4AC3-AA8D-1F4CF0BBB40E}" type="datetimeFigureOut">
               <a:rPr lang="en-US" smtClean="0"/>
-              <a:t>5/27/2026</a:t>
+              <a:t>5/29/2026</a:t>
             </a:fld>
             <a:endParaRPr lang="en-US"/>
           </a:p>
@@ -2738,7 +2738,7 @@
           <p:cNvPr id="6" name="Footer Placeholder 5">
             <a:extLst>
               <a:ext uri="{FF2B5EF4-FFF2-40B4-BE49-F238E27FC236}">
-                <a16:creationId xmlns:a16="http://schemas.microsoft.com/office/drawing/2014/main" id="{E4D74AA2-B8D1-13FA-4674-CAD61E3423B7}"/>
+                <a16:creationId xmlns:a16="http://schemas.microsoft.com/office/drawing/2014/main" id="{113D0551-1533-580C-4590-591743A579F1}"/>
               </a:ext>
             </a:extLst>
           </p:cNvPr>
@@ -2763,7 +2763,7 @@
           <p:cNvPr id="7" name="Slide Number Placeholder 6">
             <a:extLst>
               <a:ext uri="{FF2B5EF4-FFF2-40B4-BE49-F238E27FC236}">
-                <a16:creationId xmlns:a16="http://schemas.microsoft.com/office/drawing/2014/main" id="{F76FC519-C9C4-56D3-49F0-ACEE13764BB2}"/>
+                <a16:creationId xmlns:a16="http://schemas.microsoft.com/office/drawing/2014/main" id="{BFABEC6C-0057-D257-BC8E-F1A42B5C3007}"/>
               </a:ext>
             </a:extLst>
           </p:cNvPr>
@@ -2779,7 +2779,7 @@
           <a:bodyPr/>
           <a:lstStyle/>
           <a:p>
-            <a:fld id="{48E85829-D41B-4648-A682-E9D6673B9551}" type="slidenum">
+            <a:fld id="{FCF75339-8D65-4A28-B981-2E330DC017BD}" type="slidenum">
               <a:rPr lang="en-US" smtClean="0"/>
               <a:t>‹#›</a:t>
             </a:fld>
@@ -2790,7 +2790,7 @@
     </p:spTree>
     <p:extLst>
       <p:ext uri="{BB962C8B-B14F-4D97-AF65-F5344CB8AC3E}">
-        <p14:creationId xmlns:p14="http://schemas.microsoft.com/office/powerpoint/2010/main" val="222665481"/>
+        <p14:creationId xmlns:p14="http://schemas.microsoft.com/office/powerpoint/2010/main" val="3132133797"/>
       </p:ext>
     </p:extLst>
   </p:cSld>
@@ -2822,7 +2822,7 @@
           <p:cNvPr id="2" name="Title 1">
             <a:extLst>
               <a:ext uri="{FF2B5EF4-FFF2-40B4-BE49-F238E27FC236}">
-                <a16:creationId xmlns:a16="http://schemas.microsoft.com/office/drawing/2014/main" id="{5D2224A0-0896-93FD-C32E-E1FBBC929E1A}"/>
+                <a16:creationId xmlns:a16="http://schemas.microsoft.com/office/drawing/2014/main" id="{7C9E692C-313B-C55C-A49C-19C3CD76C75A}"/>
               </a:ext>
             </a:extLst>
           </p:cNvPr>
@@ -2859,7 +2859,7 @@
           <p:cNvPr id="3" name="Picture Placeholder 2">
             <a:extLst>
               <a:ext uri="{FF2B5EF4-FFF2-40B4-BE49-F238E27FC236}">
-                <a16:creationId xmlns:a16="http://schemas.microsoft.com/office/drawing/2014/main" id="{59560A7E-3157-A8C5-7BEB-C11F4D02DD95}"/>
+                <a16:creationId xmlns:a16="http://schemas.microsoft.com/office/drawing/2014/main" id="{B69D7882-9D3C-DEAE-9EAA-3838D41495F2}"/>
               </a:ext>
             </a:extLst>
           </p:cNvPr>
@@ -2926,7 +2926,7 @@
           <p:cNvPr id="4" name="Text Placeholder 3">
             <a:extLst>
               <a:ext uri="{FF2B5EF4-FFF2-40B4-BE49-F238E27FC236}">
-                <a16:creationId xmlns:a16="http://schemas.microsoft.com/office/drawing/2014/main" id="{ED01CA26-924D-5F0E-6566-B1733184FC92}"/>
+                <a16:creationId xmlns:a16="http://schemas.microsoft.com/office/drawing/2014/main" id="{BAA93885-873E-0FAE-E9BE-2D29B7A6ACAB}"/>
               </a:ext>
             </a:extLst>
           </p:cNvPr>
@@ -2997,7 +2997,7 @@
           <p:cNvPr id="5" name="Date Placeholder 4">
             <a:extLst>
               <a:ext uri="{FF2B5EF4-FFF2-40B4-BE49-F238E27FC236}">
-                <a16:creationId xmlns:a16="http://schemas.microsoft.com/office/drawing/2014/main" id="{5E42942C-1EBF-0370-1CF2-B1A5C72F9C03}"/>
+                <a16:creationId xmlns:a16="http://schemas.microsoft.com/office/drawing/2014/main" id="{A31651CA-FD5F-31E7-035C-32714FDDD1FA}"/>
               </a:ext>
             </a:extLst>
           </p:cNvPr>
@@ -3013,9 +3013,9 @@
           <a:bodyPr/>
           <a:lstStyle/>
           <a:p>
-            <a:fld id="{918732F9-E82D-415A-A9D3-0AF6537188C2}" type="datetimeFigureOut">
+            <a:fld id="{AA7B01AA-FD43-4AC3-AA8D-1F4CF0BBB40E}" type="datetimeFigureOut">
               <a:rPr lang="en-US" smtClean="0"/>
-              <a:t>5/27/2026</a:t>
+              <a:t>5/29/2026</a:t>
             </a:fld>
             <a:endParaRPr lang="en-US"/>
           </a:p>
@@ -3026,7 +3026,7 @@
           <p:cNvPr id="6" name="Footer Placeholder 5">
             <a:extLst>
               <a:ext uri="{FF2B5EF4-FFF2-40B4-BE49-F238E27FC236}">
-                <a16:creationId xmlns:a16="http://schemas.microsoft.com/office/drawing/2014/main" id="{332F48A9-24C4-145A-0ED6-3A50250214DB}"/>
+                <a16:creationId xmlns:a16="http://schemas.microsoft.com/office/drawing/2014/main" id="{E7D0A4D6-64CB-A752-1E15-3E3B18B7430D}"/>
               </a:ext>
             </a:extLst>
           </p:cNvPr>
@@ -3051,7 +3051,7 @@
           <p:cNvPr id="7" name="Slide Number Placeholder 6">
             <a:extLst>
               <a:ext uri="{FF2B5EF4-FFF2-40B4-BE49-F238E27FC236}">
-                <a16:creationId xmlns:a16="http://schemas.microsoft.com/office/drawing/2014/main" id="{3014F024-9722-B064-8234-64962CDCF06F}"/>
+                <a16:creationId xmlns:a16="http://schemas.microsoft.com/office/drawing/2014/main" id="{C839ADF2-15EA-083F-9A12-2ACFEC4062F8}"/>
               </a:ext>
             </a:extLst>
           </p:cNvPr>
@@ -3067,7 +3067,7 @@
           <a:bodyPr/>
           <a:lstStyle/>
           <a:p>
-            <a:fld id="{48E85829-D41B-4648-A682-E9D6673B9551}" type="slidenum">
+            <a:fld id="{FCF75339-8D65-4A28-B981-2E330DC017BD}" type="slidenum">
               <a:rPr lang="en-US" smtClean="0"/>
               <a:t>‹#›</a:t>
             </a:fld>
@@ -3078,7 +3078,7 @@
     </p:spTree>
     <p:extLst>
       <p:ext uri="{BB962C8B-B14F-4D97-AF65-F5344CB8AC3E}">
-        <p14:creationId xmlns:p14="http://schemas.microsoft.com/office/powerpoint/2010/main" val="2125858550"/>
+        <p14:creationId xmlns:p14="http://schemas.microsoft.com/office/powerpoint/2010/main" val="3210424410"/>
       </p:ext>
     </p:extLst>
   </p:cSld>
@@ -3115,7 +3115,7 @@
           <p:cNvPr id="2" name="Title Placeholder 1">
             <a:extLst>
               <a:ext uri="{FF2B5EF4-FFF2-40B4-BE49-F238E27FC236}">
-                <a16:creationId xmlns:a16="http://schemas.microsoft.com/office/drawing/2014/main" id="{1370C4BA-D541-C05B-05F3-28C9815E3F6A}"/>
+                <a16:creationId xmlns:a16="http://schemas.microsoft.com/office/drawing/2014/main" id="{878ADF5A-FBB4-6009-5DF0-F2905069F009}"/>
               </a:ext>
             </a:extLst>
           </p:cNvPr>
@@ -3153,7 +3153,7 @@
           <p:cNvPr id="3" name="Text Placeholder 2">
             <a:extLst>
               <a:ext uri="{FF2B5EF4-FFF2-40B4-BE49-F238E27FC236}">
-                <a16:creationId xmlns:a16="http://schemas.microsoft.com/office/drawing/2014/main" id="{87D6AD4E-274C-A32F-9267-ACCF83D4C04E}"/>
+                <a16:creationId xmlns:a16="http://schemas.microsoft.com/office/drawing/2014/main" id="{64DE43E2-C8B6-D66B-6764-582A286D9F2D}"/>
               </a:ext>
             </a:extLst>
           </p:cNvPr>
@@ -3220,7 +3220,7 @@
           <p:cNvPr id="4" name="Date Placeholder 3">
             <a:extLst>
               <a:ext uri="{FF2B5EF4-FFF2-40B4-BE49-F238E27FC236}">
-                <a16:creationId xmlns:a16="http://schemas.microsoft.com/office/drawing/2014/main" id="{703FE71A-B23E-3B6C-A24F-48D23BCD4018}"/>
+                <a16:creationId xmlns:a16="http://schemas.microsoft.com/office/drawing/2014/main" id="{F133D263-0D0C-58EA-32C2-04620526D138}"/>
               </a:ext>
             </a:extLst>
           </p:cNvPr>
@@ -3254,9 +3254,9 @@
             </a:lvl1pPr>
           </a:lstStyle>
           <a:p>
-            <a:fld id="{918732F9-E82D-415A-A9D3-0AF6537188C2}" type="datetimeFigureOut">
+            <a:fld id="{AA7B01AA-FD43-4AC3-AA8D-1F4CF0BBB40E}" type="datetimeFigureOut">
               <a:rPr lang="en-US" smtClean="0"/>
-              <a:t>5/27/2026</a:t>
+              <a:t>5/29/2026</a:t>
             </a:fld>
             <a:endParaRPr lang="en-US"/>
           </a:p>
@@ -3267,7 +3267,7 @@
           <p:cNvPr id="5" name="Footer Placeholder 4">
             <a:extLst>
               <a:ext uri="{FF2B5EF4-FFF2-40B4-BE49-F238E27FC236}">
-                <a16:creationId xmlns:a16="http://schemas.microsoft.com/office/drawing/2014/main" id="{B9FFEA23-639F-7091-DF94-299BC3E701D6}"/>
+                <a16:creationId xmlns:a16="http://schemas.microsoft.com/office/drawing/2014/main" id="{46860D15-6386-2C17-B344-AF0C7AD13FDE}"/>
               </a:ext>
             </a:extLst>
           </p:cNvPr>
@@ -3310,7 +3310,7 @@
           <p:cNvPr id="6" name="Slide Number Placeholder 5">
             <a:extLst>
               <a:ext uri="{FF2B5EF4-FFF2-40B4-BE49-F238E27FC236}">
-                <a16:creationId xmlns:a16="http://schemas.microsoft.com/office/drawing/2014/main" id="{777CDFD5-4726-190A-C5BF-0942BE41B0EE}"/>
+                <a16:creationId xmlns:a16="http://schemas.microsoft.com/office/drawing/2014/main" id="{D40E2734-3B48-0B7C-7B05-A340B1FB6213}"/>
               </a:ext>
             </a:extLst>
           </p:cNvPr>
@@ -3344,7 +3344,7 @@
             </a:lvl1pPr>
           </a:lstStyle>
           <a:p>
-            <a:fld id="{48E85829-D41B-4648-A682-E9D6673B9551}" type="slidenum">
+            <a:fld id="{FCF75339-8D65-4A28-B981-2E330DC017BD}" type="slidenum">
               <a:rPr lang="en-US" smtClean="0"/>
               <a:t>‹#›</a:t>
             </a:fld>
@@ -3355,7 +3355,7 @@
     </p:spTree>
     <p:extLst>
       <p:ext uri="{BB962C8B-B14F-4D97-AF65-F5344CB8AC3E}">
-        <p14:creationId xmlns:p14="http://schemas.microsoft.com/office/powerpoint/2010/main" val="1209212381"/>
+        <p14:creationId xmlns:p14="http://schemas.microsoft.com/office/powerpoint/2010/main" val="2588986153"/>
       </p:ext>
     </p:extLst>
   </p:cSld>
@@ -3678,7 +3678,7 @@
           <p:cNvPr id="2" name="Chart 1">
             <a:extLst>
               <a:ext uri="{FF2B5EF4-FFF2-40B4-BE49-F238E27FC236}">
-                <a16:creationId xmlns:a16="http://schemas.microsoft.com/office/drawing/2014/main" id="{A5EE690E-D612-B462-6E42-47B5989CE7A1}"/>
+                <a16:creationId xmlns:a16="http://schemas.microsoft.com/office/drawing/2014/main" id="{108420A0-098C-F3FE-FF56-D835D40B9803}"/>
               </a:ext>
             </a:extLst>
           </p:cNvPr>
@@ -3686,7 +3686,7 @@
           <p:nvPr>
             <p:extLst>
               <p:ext uri="{D42A27DB-BD31-4B8C-83A1-F6EECF244321}">
-                <p14:modId xmlns:p14="http://schemas.microsoft.com/office/powerpoint/2010/main" val="3644798115"/>
+                <p14:modId xmlns:p14="http://schemas.microsoft.com/office/powerpoint/2010/main" val="83152487"/>
               </p:ext>
             </p:extLst>
           </p:nvPr>
@@ -3704,7 +3704,7 @@
     </p:spTree>
     <p:extLst>
       <p:ext uri="{BB962C8B-B14F-4D97-AF65-F5344CB8AC3E}">
-        <p14:creationId xmlns:p14="http://schemas.microsoft.com/office/powerpoint/2010/main" val="1463768847"/>
+        <p14:creationId xmlns:p14="http://schemas.microsoft.com/office/powerpoint/2010/main" val="703272004"/>
       </p:ext>
     </p:extLst>
   </p:cSld>

</xml_diff>